<commit_message>
Consolidate the nine-feature operational workflow and remove legacy artifacts.
</commit_message>
<xml_diff>
--- a/reports/presentation/v2_wildfire_exposure_screening_capstone_presentation.pptx
+++ b/reports/presentation/v2_wildfire_exposure_screening_capstone_presentation.pptx
@@ -2,25 +2,25 @@
 <file path=ppt/presentation.xml><?xml version="1.0" encoding="utf-8"?>
 <p:presentation xmlns:p="http://schemas.openxmlformats.org/presentationml/2006/main">
   <p:sldMasterIdLst>
-    <p:sldMasterId xmlns:r="http://schemas.openxmlformats.org/officeDocument/2006/relationships" id="2147483648" r:id="Ra4d1e547b4dd40aa"/>
+    <p:sldMasterId xmlns:r="http://schemas.openxmlformats.org/officeDocument/2006/relationships" id="2147483648" r:id="Rf447278a742a46ab"/>
   </p:sldMasterIdLst>
   <p:notesMasterIdLst>
-    <p:notesMasterId xmlns:r="http://schemas.openxmlformats.org/officeDocument/2006/relationships" r:id="Rf12b7e1a702948c8"/>
+    <p:notesMasterId xmlns:r="http://schemas.openxmlformats.org/officeDocument/2006/relationships" r:id="R65fc1dd77bca4a4a"/>
   </p:notesMasterIdLst>
   <p:sldIdLst>
-    <p:sldId xmlns:r="http://schemas.openxmlformats.org/officeDocument/2006/relationships" id="256" r:id="R9805a8792273422d"/>
-    <p:sldId xmlns:r="http://schemas.openxmlformats.org/officeDocument/2006/relationships" id="257" r:id="Rcda2581114574be0"/>
-    <p:sldId xmlns:r="http://schemas.openxmlformats.org/officeDocument/2006/relationships" id="258" r:id="R4f63a36c40d740bc"/>
-    <p:sldId xmlns:r="http://schemas.openxmlformats.org/officeDocument/2006/relationships" id="259" r:id="R953ecee8d808444e"/>
-    <p:sldId xmlns:r="http://schemas.openxmlformats.org/officeDocument/2006/relationships" id="260" r:id="Raa861ab870104045"/>
-    <p:sldId xmlns:r="http://schemas.openxmlformats.org/officeDocument/2006/relationships" id="261" r:id="Rceb2a07d0c074d6f"/>
-    <p:sldId xmlns:r="http://schemas.openxmlformats.org/officeDocument/2006/relationships" id="262" r:id="Rea05e432c0da4ae9"/>
-    <p:sldId xmlns:r="http://schemas.openxmlformats.org/officeDocument/2006/relationships" id="263" r:id="Ra8289618dc054c8d"/>
-    <p:sldId xmlns:r="http://schemas.openxmlformats.org/officeDocument/2006/relationships" id="264" r:id="R0fe64498ae644732"/>
-    <p:sldId xmlns:r="http://schemas.openxmlformats.org/officeDocument/2006/relationships" id="265" r:id="Rcc2bc343d80543c0"/>
-    <p:sldId xmlns:r="http://schemas.openxmlformats.org/officeDocument/2006/relationships" id="266" r:id="R0fa7f59dc16645dd"/>
-    <p:sldId xmlns:r="http://schemas.openxmlformats.org/officeDocument/2006/relationships" id="267" r:id="R7e164044ead54272"/>
-    <p:sldId xmlns:r="http://schemas.openxmlformats.org/officeDocument/2006/relationships" id="268" r:id="R9e3d6fb633e64ccf"/>
+    <p:sldId xmlns:r="http://schemas.openxmlformats.org/officeDocument/2006/relationships" id="256" r:id="Rc30e905a36f84a1a"/>
+    <p:sldId xmlns:r="http://schemas.openxmlformats.org/officeDocument/2006/relationships" id="257" r:id="Ref8b0f06bc9f48c0"/>
+    <p:sldId xmlns:r="http://schemas.openxmlformats.org/officeDocument/2006/relationships" id="258" r:id="Rb87d82ec033642be"/>
+    <p:sldId xmlns:r="http://schemas.openxmlformats.org/officeDocument/2006/relationships" id="259" r:id="Re3ba5cf09937400f"/>
+    <p:sldId xmlns:r="http://schemas.openxmlformats.org/officeDocument/2006/relationships" id="260" r:id="Ra56c93880690415b"/>
+    <p:sldId xmlns:r="http://schemas.openxmlformats.org/officeDocument/2006/relationships" id="261" r:id="Rf22deaba3cf24876"/>
+    <p:sldId xmlns:r="http://schemas.openxmlformats.org/officeDocument/2006/relationships" id="262" r:id="R26cae7a254314236"/>
+    <p:sldId xmlns:r="http://schemas.openxmlformats.org/officeDocument/2006/relationships" id="263" r:id="R00b26111c6fd4be2"/>
+    <p:sldId xmlns:r="http://schemas.openxmlformats.org/officeDocument/2006/relationships" id="264" r:id="Rb201b8953be14249"/>
+    <p:sldId xmlns:r="http://schemas.openxmlformats.org/officeDocument/2006/relationships" id="265" r:id="R02b486785d5d4eae"/>
+    <p:sldId xmlns:r="http://schemas.openxmlformats.org/officeDocument/2006/relationships" id="266" r:id="R83a1fa21b8914c29"/>
+    <p:sldId xmlns:r="http://schemas.openxmlformats.org/officeDocument/2006/relationships" id="267" r:id="Rd7d61544ab984904"/>
+    <p:sldId xmlns:r="http://schemas.openxmlformats.org/officeDocument/2006/relationships" id="268" r:id="R2625fe937ad84dd5"/>
   </p:sldIdLst>
   <p:sldSz cx="12192000" cy="6858000"/>
   <p:notesSz cx="6858000" cy="9144000"/>
@@ -454,7 +454,7 @@
           <a:lstStyle xmlns:a="http://schemas.openxmlformats.org/drawingml/2006/main"/>
           <a:p xmlns:a="http://schemas.openxmlformats.org/drawingml/2006/main">
             <a:r>
-              <a:t>I will present a capstone that began as a next-year wildfire-exposure modelling experiment and ended with a deliberately more cautious result. I tested whether a national set of land-cover, terrain, climate, and fire-history predictors could outperform a transparent historical-recurrence reference. The tested regressions did not pass the predefined validation gate, so I did not advance them to final testing or publish a predictive layer. Instead, the project delivers a reproducible historical screening for broad location comparison across mainland Portugal.</a:t>
+              <a:t>This capstone now has two clearly separated outputs. First, the historical screening summarises observed 2016–2025 fire recurrence for broad location comparison. Second, a fixed nine-feature hurdle model was evaluated on untouched predictor years 2022–2024, then refit through observed 2025 outcomes to publish a target-free 2026 comparative estimate. Neither output is a property-level safety forecast or purchase recommendation.</a:t>
             </a:r>
           </a:p>
           <a:p xmlns:a="http://schemas.openxmlformats.org/drawingml/2006/main">
@@ -464,7 +464,7 @@
           </a:p>
           <a:p xmlns:a="http://schemas.openxmlformats.org/drawingml/2006/main">
             <a:r>
-              <a:t>Key takeaway for the assessor: the value of the project is both the validated GIS deliverable and the evidence-based decision not to overclaim predictive performance.</a:t>
+              <a:t>Key takeaway: the project moved from exploratory modelling to a governed annual model cycle while retaining historical recurrence as an interpretable reference.</a:t>
             </a:r>
           </a:p>
           <a:p xmlns:a="http://schemas.openxmlformats.org/drawingml/2006/main">
@@ -474,16 +474,6 @@
           </a:p>
           <a:p xmlns:a="http://schemas.openxmlformats.org/drawingml/2006/main">
             <a:r>
-              <a:t>Methodological nuance: the final exposure bands come directly from observed ICNF burned-area history; they are not Random Forest or Tweedie outputs.</a:t>
-            </a:r>
-          </a:p>
-          <a:p xmlns:a="http://schemas.openxmlformats.org/drawingml/2006/main">
-            <a:r>
-              <a:t/>
-            </a:r>
-          </a:p>
-          <a:p xmlns:a="http://schemas.openxmlformats.org/drawingml/2006/main">
-            <a:r>
               <a:t>[Sources]</a:t>
             </a:r>
           </a:p>
@@ -494,17 +484,22 @@
           </a:p>
           <a:p xmlns:a="http://schemas.openxmlformats.org/drawingml/2006/main">
             <a:r>
-              <a:t>- reports/validation/train_validation_model_selection.md</a:t>
+              <a:t>- reports/validation/final_temporal_test_2022_2024.md</a:t>
+            </a:r>
+          </a:p>
+          <a:p xmlns:a="http://schemas.openxmlformats.org/drawingml/2006/main">
+            <a:r>
+              <a:t>- reports/validation/model_final_decision.md</a:t>
+            </a:r>
+          </a:p>
+          <a:p xmlns:a="http://schemas.openxmlformats.org/drawingml/2006/main">
+            <a:r>
+              <a:t>- reports/validation/operational_forecast_2026_validation.md</a:t>
             </a:r>
           </a:p>
           <a:p xmlns:a="http://schemas.openxmlformats.org/drawingml/2006/main">
             <a:r>
               <a:t>- reports/validation/historical_exposure_screening_and_icnf_comparison.md</a:t>
-            </a:r>
-          </a:p>
-          <a:p xmlns:a="http://schemas.openxmlformats.org/drawingml/2006/main">
-            <a:r>
-              <a:t>- docs/Capstone_Kickoff_Workbook_Serhii_Diadechko.docx</a:t>
             </a:r>
           </a:p>
         </p:txBody>
@@ -834,7 +829,7 @@
           <a:lstStyle xmlns:a="http://schemas.openxmlformats.org/drawingml/2006/main"/>
           <a:p xmlns:a="http://schemas.openxmlformats.org/drawingml/2006/main">
             <a:r>
-              <a:t>I close with the evidence-led project decision. Historical recurrence was the strongest validated evidence for comparative screening. The tested regressions were not selected because neither met the predefined combination of MAE, RMSE, and ranking evidence. The project therefore delivers a reproducible national screening layer, a portable QGIS project that presents the same validated GeoPackage, and a complete set of figures, tables, reports, notebooks, and this presentation.</a:t>
+              <a:t>The project retains two complementary products. Historical recurrence is a directly interpretable observed-evidence screening layer. The frozen nine-feature hurdle was evaluated on untouched 2022–2024 predictor years, refit through observed 2025 outcomes, and used to publish a target-free 2026 comparative estimate. Its high-burn calibration limitation is explicit.</a:t>
             </a:r>
           </a:p>
           <a:p xmlns:a="http://schemas.openxmlformats.org/drawingml/2006/main">
@@ -844,7 +839,7 @@
           </a:p>
           <a:p xmlns:a="http://schemas.openxmlformats.org/drawingml/2006/main">
             <a:r>
-              <a:t>Key takeaway for the assessor: the project succeeded as a rigorous and inspectable GIS screening workflow, while explicitly not succeeding as an accepted next-year predictive model.</a:t>
+              <a:t>Appropriate use is broad 1 km location comparison followed by local due diligence. Neither product is a safety guarantee, probability, insurance estimate, or purchase recommendation.</a:t>
             </a:r>
           </a:p>
           <a:p xmlns:a="http://schemas.openxmlformats.org/drawingml/2006/main">
@@ -854,47 +849,22 @@
           </a:p>
           <a:p xmlns:a="http://schemas.openxmlformats.org/drawingml/2006/main">
             <a:r>
-              <a:t>Methodological nuance: appropriate use is broad location comparison and follow-up due diligence. The outputs exclude building vulnerability, ignition likelihood, evacuation access, suppression conditions, and damage assessment.</a:t>
-            </a:r>
-          </a:p>
-          <a:p xmlns:a="http://schemas.openxmlformats.org/drawingml/2006/main">
-            <a:r>
-              <a:t/>
-            </a:r>
-          </a:p>
-          <a:p xmlns:a="http://schemas.openxmlformats.org/drawingml/2006/main">
-            <a:r>
-              <a:t>Likely assessor question and answer</a:t>
-            </a:r>
-          </a:p>
-          <a:p xmlns:a="http://schemas.openxmlformats.org/drawingml/2006/main">
-            <a:r>
-              <a:t>Was the project successful? Yes against its evidence-based workflow criteria, but not as a next-year prediction project—and that limitation is explicit.</a:t>
-            </a:r>
-          </a:p>
-          <a:p xmlns:a="http://schemas.openxmlformats.org/drawingml/2006/main">
-            <a:r>
-              <a:t/>
-            </a:r>
-          </a:p>
-          <a:p xmlns:a="http://schemas.openxmlformats.org/drawingml/2006/main">
-            <a:r>
               <a:t>[Sources]</a:t>
             </a:r>
           </a:p>
           <a:p xmlns:a="http://schemas.openxmlformats.org/drawingml/2006/main">
             <a:r>
-              <a:t>- reports/figures/historical_exposure_screening_decision_limitations.png</a:t>
+              <a:t>- reports/validation/model_final_decision.md</a:t>
+            </a:r>
+          </a:p>
+          <a:p xmlns:a="http://schemas.openxmlformats.org/drawingml/2006/main">
+            <a:r>
+              <a:t>- reports/validation/operational_forecast_2026_validation.md</a:t>
             </a:r>
           </a:p>
           <a:p xmlns:a="http://schemas.openxmlformats.org/drawingml/2006/main">
             <a:r>
               <a:t>- reports/validation/spatial_output_registry.md</a:t>
-            </a:r>
-          </a:p>
-          <a:p xmlns:a="http://schemas.openxmlformats.org/drawingml/2006/main">
-            <a:r>
-              <a:t>- reports/validation/qgis_presentation_project_validation.md</a:t>
             </a:r>
           </a:p>
           <a:p xmlns:a="http://schemas.openxmlformats.org/drawingml/2006/main">
@@ -974,12 +944,7 @@
           <a:lstStyle xmlns:a="http://schemas.openxmlformats.org/drawingml/2006/main"/>
           <a:p xmlns:a="http://schemas.openxmlformats.org/drawingml/2006/main">
             <a:r>
-              <a:t>Why analyse all mainland Portugal rather than one region?</a:t>
-            </a:r>
-          </a:p>
-          <a:p xmlns:a="http://schemas.openxmlformats.org/drawingml/2006/main">
-            <a:r>
-              <a:t>The buyer's initial decision is national: first compare broad candidate areas, then investigate shortlisted places locally. A national 1 km grid applies one consistent method across the full range of Portuguese wildfire conditions and provides enough observations for an honest temporal ML experiment. The result is a national screening layer, not a replacement for local property-level assessment.</a:t>
+              <a:t>Why all mainland Portugal? The buyer's first comparison can be national, followed by local property checks.</a:t>
             </a:r>
           </a:p>
           <a:p xmlns:a="http://schemas.openxmlformats.org/drawingml/2006/main">
@@ -989,12 +954,7 @@
           </a:p>
           <a:p xmlns:a="http://schemas.openxmlformats.org/drawingml/2006/main">
             <a:r>
-              <a:t>What was the hypothesis, and what was the result?</a:t>
-            </a:r>
-          </a:p>
-          <a:p xmlns:a="http://schemas.openxmlformats.org/drawingml/2006/main">
-            <a:r>
-              <a:t>The hypothesis was that land cover, terrain, climate-related context, and historical-fire information could improve next-year wildfire prioritisation compared with a transparent historical-recurrence reference. The hypothesis was not supported: Random Forest and Tweedie did not pass the predefined validation gate, with Capture@20% of 28.62% and 49.46%, compared with 55.88% for historical recurrence. No predictive model was selected.</a:t>
+              <a:t>What was tested? A frozen historical-recurrence baseline and a nine-feature hurdle model under separated fit, validation, and final-test years.</a:t>
             </a:r>
           </a:p>
           <a:p xmlns:a="http://schemas.openxmlformats.org/drawingml/2006/main">
@@ -1004,12 +964,7 @@
           </a:p>
           <a:p xmlns:a="http://schemas.openxmlformats.org/drawingml/2006/main">
             <a:r>
-              <a:t>Were the features chosen correctly, and were they sufficient?</a:t>
-            </a:r>
-          </a:p>
-          <a:p xmlns:a="http://schemas.openxmlformats.org/drawingml/2006/main">
-            <a:r>
-              <a:t>The features were appropriate for an initial reproducible national experiment: historical recurrence, land-cover context, terrain, and climate-related context. However, validation showed they were not sufficient—at this resolution and with this modelling design—to justify a reliable next-year predictive model. Future work needs additional temporally valid information such as ignition sources, fuel condition, wind extremes, access, suppression context, and property vulnerability.</a:t>
+              <a:t>What was the result? On T=2022–2024, the hurdle improved MAE from 0.0292 to 0.0214 and Capture@20% from 48.2% to 50.0%; RMSE remained about 0.111 and the high-burn T=2024 outcome was underpredicted.</a:t>
             </a:r>
           </a:p>
           <a:p xmlns:a="http://schemas.openxmlformats.org/drawingml/2006/main">
@@ -1019,12 +974,7 @@
           </a:p>
           <a:p xmlns:a="http://schemas.openxmlformats.org/drawingml/2006/main">
             <a:r>
-              <a:t>Was the project successful?</a:t>
-            </a:r>
-          </a:p>
-          <a:p xmlns:a="http://schemas.openxmlformats.org/drawingml/2006/main">
-            <a:r>
-              <a:t>Yes, according to its evidence-based success criteria. It delivered a reproducible national GIS workflow, evaluated predictive models honestly, avoided publishing an insufficient predictive model, and produced an interpretable historical-exposure screening with an independent official ICNF comparison. It was not successful as a next-year prediction project, and that is stated clearly.</a:t>
+              <a:t>Was the project successful? Yes as a reproducible, governed comparative-exposure project. The 2026 target-free model estimate and the 2016–2025 historical screening are separate products with explicit limitations.</a:t>
             </a:r>
           </a:p>
           <a:p xmlns:a="http://schemas.openxmlformats.org/drawingml/2006/main">
@@ -1034,12 +984,7 @@
           </a:p>
           <a:p xmlns:a="http://schemas.openxmlformats.org/drawingml/2006/main">
             <a:r>
-              <a:t>If the ML models did not perform sufficiently well, why can the final classification still support a buyer?</a:t>
-            </a:r>
-          </a:p>
-          <a:p xmlns:a="http://schemas.openxmlformats.org/drawingml/2006/main">
-            <a:r>
-              <a:t>Because the final classification is not the output of the unselected ML models. It is a transparent summary of observed fire recurrence from 2016–2025. The project tested whether ML could add a reliable next-year predictive layer; it could not, so that claim was not made. The historical classes still provide reproducible evidence for comparing broad locations and deciding where further local investigation is most justified.</a:t>
+              <a:t>Why keep recurrence? It is transparent observed evidence and a useful reference, not a next-year model output.</a:t>
             </a:r>
           </a:p>
           <a:p xmlns:a="http://schemas.openxmlformats.org/drawingml/2006/main">
@@ -1049,52 +994,27 @@
           </a:p>
           <a:p xmlns:a="http://schemas.openxmlformats.org/drawingml/2006/main">
             <a:r>
-              <a:t>Why retain historical recurrence if it is not a prediction?</a:t>
-            </a:r>
-          </a:p>
-          <a:p xmlns:a="http://schemas.openxmlformats.org/drawingml/2006/main">
-            <a:r>
-              <a:t>Historical recurrence was retained because it was the strongest validated evidence for comparative prioritisation. It identifies areas repeatedly affected in the 2016–2025 record, but is presented strictly as historical exposure, not as the probability of fire next year.</a:t>
-            </a:r>
-          </a:p>
-          <a:p xmlns:a="http://schemas.openxmlformats.org/drawingml/2006/main">
-            <a:r>
-              <a:t/>
-            </a:r>
-          </a:p>
-          <a:p xmlns:a="http://schemas.openxmlformats.org/drawingml/2006/main">
-            <a:r>
-              <a:t>Key takeaway for the assessor: the conclusions follow the validation evidence and the final classification remains conceptually separate from the rejected regressions.</a:t>
-            </a:r>
-          </a:p>
-          <a:p xmlns:a="http://schemas.openxmlformats.org/drawingml/2006/main">
-            <a:r>
-              <a:t/>
-            </a:r>
-          </a:p>
-          <a:p xmlns:a="http://schemas.openxmlformats.org/drawingml/2006/main">
-            <a:r>
               <a:t>[Sources]</a:t>
             </a:r>
           </a:p>
           <a:p xmlns:a="http://schemas.openxmlformats.org/drawingml/2006/main">
             <a:r>
-              <a:t>- reports/validation/train_validation_model_selection.md</a:t>
+              <a:t>- reports/validation/final_temporal_test_2022_2024.md</a:t>
+            </a:r>
+          </a:p>
+          <a:p xmlns:a="http://schemas.openxmlformats.org/drawingml/2006/main">
+            <a:r>
+              <a:t>- reports/validation/model_final_decision.md</a:t>
+            </a:r>
+          </a:p>
+          <a:p xmlns:a="http://schemas.openxmlformats.org/drawingml/2006/main">
+            <a:r>
+              <a:t>- reports/validation/operational_forecast_2026_validation.md</a:t>
             </a:r>
           </a:p>
           <a:p xmlns:a="http://schemas.openxmlformats.org/drawingml/2006/main">
             <a:r>
               <a:t>- reports/validation/historical_exposure_screening_and_icnf_comparison.md</a:t>
-            </a:r>
-          </a:p>
-          <a:p xmlns:a="http://schemas.openxmlformats.org/drawingml/2006/main">
-            <a:r>
-              <a:t>- reports/validation/spatial_output_registry.md</a:t>
-            </a:r>
-          </a:p>
-          <a:p xmlns:a="http://schemas.openxmlformats.org/drawingml/2006/main">
-            <a:r>
-              <a:t>- docs/success_criteria.md</a:t>
             </a:r>
           </a:p>
         </p:txBody>
@@ -1294,7 +1214,7 @@
           <a:lstStyle xmlns:a="http://schemas.openxmlformats.org/drawingml/2006/main"/>
           <a:p xmlns:a="http://schemas.openxmlformats.org/drawingml/2006/main">
             <a:r>
-              <a:t>I analysed all mainland Portugal because the buyer's first choice can be national: compare broad candidate areas, then investigate shortlisted places locally. A national grid applies the same definitions to the north, centre, interior, coast, and south rather than changing methods by region. It also supplied enough cell-year records to test next-year regression models under a strict temporal split.</a:t>
+              <a:t>All mainland Portugal was analysed because the buyer's first comparison can be national: compare broad candidate areas, then investigate shortlisted places locally. The canonical grid has 89,112 cells. Model development uses 15 labelled predictor years from 2010 through 2024, with outcomes through 2025, while the historical screening GeoPackage stores one geometry per cell.</a:t>
             </a:r>
           </a:p>
           <a:p xmlns:a="http://schemas.openxmlformats.org/drawingml/2006/main">
@@ -1304,7 +1224,7 @@
           </a:p>
           <a:p xmlns:a="http://schemas.openxmlformats.org/drawingml/2006/main">
             <a:r>
-              <a:t>Key takeaway for the assessor: national coverage is a decision-design choice and a reproducibility advantage, not an attempt to claim property-level precision.</a:t>
+              <a:t>Key takeaway: national coverage is a consistent decision framework, not a claim of property-level precision.</a:t>
             </a:r>
           </a:p>
           <a:p xmlns:a="http://schemas.openxmlformats.org/drawingml/2006/main">
@@ -1314,31 +1234,6 @@
           </a:p>
           <a:p xmlns:a="http://schemas.openxmlformats.org/drawingml/2006/main">
             <a:r>
-              <a:t>Methodological nuance: the national analytical panel contains repeated cell-year records for modelling, while the final screening GeoPackage contains one geometry per canonical cell.</a:t>
-            </a:r>
-          </a:p>
-          <a:p xmlns:a="http://schemas.openxmlformats.org/drawingml/2006/main">
-            <a:r>
-              <a:t/>
-            </a:r>
-          </a:p>
-          <a:p xmlns:a="http://schemas.openxmlformats.org/drawingml/2006/main">
-            <a:r>
-              <a:t>Likely assessor question and answer</a:t>
-            </a:r>
-          </a:p>
-          <a:p xmlns:a="http://schemas.openxmlformats.org/drawingml/2006/main">
-            <a:r>
-              <a:t>Why not begin with one region? A regional scope would not answer the buyer's initial national comparison and would reduce the range of conditions available for temporal validation.</a:t>
-            </a:r>
-          </a:p>
-          <a:p xmlns:a="http://schemas.openxmlformats.org/drawingml/2006/main">
-            <a:r>
-              <a:t/>
-            </a:r>
-          </a:p>
-          <a:p xmlns:a="http://schemas.openxmlformats.org/drawingml/2006/main">
-            <a:r>
               <a:t>[Sources]</a:t>
             </a:r>
           </a:p>
@@ -1350,6 +1245,11 @@
           <a:p xmlns:a="http://schemas.openxmlformats.org/drawingml/2006/main">
             <a:r>
               <a:t>- reports/validation/national_panel_2015_2024_validation.md</a:t>
+            </a:r>
+          </a:p>
+          <a:p xmlns:a="http://schemas.openxmlformats.org/drawingml/2006/main">
+            <a:r>
+              <a:t>- reports/validation/final_temporal_test_2022_2024.md</a:t>
             </a:r>
           </a:p>
           <a:p xmlns:a="http://schemas.openxmlformats.org/drawingml/2006/main">
@@ -1424,7 +1324,7 @@
           <a:lstStyle xmlns:a="http://schemas.openxmlformats.org/drawingml/2006/main"/>
           <a:p xmlns:a="http://schemas.openxmlformats.org/drawingml/2006/main">
             <a:r>
-              <a:t>I designed the workflow so that each analytical role remains explicit. Annual ICNF burned-area records supply observed historical recurrence and next-year model outcomes. The canonical 1 km grid provides the analytical unit, while selected contextual measures use an outward 2 km buffer. The model experiment adds governed land cover, terrain, climate, and strictly prior fire history. Separately, the official ICNF structural-hazard map is summarized to the same cells for descriptive comparison.</a:t>
+              <a:t>The workflow keeps three analytical roles distinct. ICNF annual burned areas provide strictly prior fire history and next-year outcomes. The model uses nine governed land-cover, terrain, climate, and history features under a temporal protocol. Separately, observed 2016–2025 recurrence is presented as historical screening and the official ICNF structural-hazard map is an independent comparison reference.</a:t>
             </a:r>
           </a:p>
           <a:p xmlns:a="http://schemas.openxmlformats.org/drawingml/2006/main">
@@ -1434,7 +1334,7 @@
           </a:p>
           <a:p xmlns:a="http://schemas.openxmlformats.org/drawingml/2006/main">
             <a:r>
-              <a:t>Key takeaway for the assessor: observed history, attempted prediction, and official structural hazard are separate evidence layers with different meanings.</a:t>
+              <a:t>Key takeaway: model estimates, observed historical screening, and official structural hazard have different meanings and are never substituted for one another.</a:t>
             </a:r>
           </a:p>
           <a:p xmlns:a="http://schemas.openxmlformats.org/drawingml/2006/main">
@@ -1444,31 +1344,6 @@
           </a:p>
           <a:p xmlns:a="http://schemas.openxmlformats.org/drawingml/2006/main">
             <a:r>
-              <a:t>Methodological nuance: all modelling features obey temporal rules; the final historical bands use the latest complete observed 2016–2025 window directly and do not depend on model output.</a:t>
-            </a:r>
-          </a:p>
-          <a:p xmlns:a="http://schemas.openxmlformats.org/drawingml/2006/main">
-            <a:r>
-              <a:t/>
-            </a:r>
-          </a:p>
-          <a:p xmlns:a="http://schemas.openxmlformats.org/drawingml/2006/main">
-            <a:r>
-              <a:t>Likely assessor question and answer</a:t>
-            </a:r>
-          </a:p>
-          <a:p xmlns:a="http://schemas.openxmlformats.org/drawingml/2006/main">
-            <a:r>
-              <a:t>Was official hazard used to train or validate the model? No. It is an independent comparison reference only.</a:t>
-            </a:r>
-          </a:p>
-          <a:p xmlns:a="http://schemas.openxmlformats.org/drawingml/2006/main">
-            <a:r>
-              <a:t/>
-            </a:r>
-          </a:p>
-          <a:p xmlns:a="http://schemas.openxmlformats.org/drawingml/2006/main">
-            <a:r>
               <a:t>[Sources]</a:t>
             </a:r>
           </a:p>
@@ -1479,17 +1354,17 @@
           </a:p>
           <a:p xmlns:a="http://schemas.openxmlformats.org/drawingml/2006/main">
             <a:r>
-              <a:t>- reports/validation/canonical_full_scope_readiness.md</a:t>
-            </a:r>
-          </a:p>
-          <a:p xmlns:a="http://schemas.openxmlformats.org/drawingml/2006/main">
-            <a:r>
-              <a:t>- reports/validation/train_validation_model_selection.md</a:t>
+              <a:t>- reports/validation/final_temporal_test_2022_2024.md</a:t>
             </a:r>
           </a:p>
           <a:p xmlns:a="http://schemas.openxmlformats.org/drawingml/2006/main">
             <a:r>
               <a:t>- reports/validation/historical_exposure_screening_and_icnf_comparison.md</a:t>
+            </a:r>
+          </a:p>
+          <a:p xmlns:a="http://schemas.openxmlformats.org/drawingml/2006/main">
+            <a:r>
+              <a:t>- docs/operational_forecast_cycle.md</a:t>
             </a:r>
           </a:p>
         </p:txBody>
@@ -1559,7 +1434,7 @@
           <a:lstStyle xmlns:a="http://schemas.openxmlformats.org/drawingml/2006/main"/>
           <a:p xmlns:a="http://schemas.openxmlformats.org/drawingml/2006/main">
             <a:r>
-              <a:t>The modelling challenge is the target distribution. Many cell-years have exactly zero burned share, so an always-zero reference can look strong on average error even though it provides no useful prioritisation. That is why I evaluated MAE and RMSE over all rows, positive-target error separately, and Capture@20%, which asks how many fire-affected rows appear in the highest-ranked fifth.</a:t>
+              <a:t>The target is zero-heavy. An always-zero reference can produce deceptively low average error while offering no useful ranking. The project therefore reports MAE and RMSE, positive-target errors, mean predicted versus observed share, and Capture@20% as a ranking diagnostic. Capture@20% is not a buyer threshold.</a:t>
             </a:r>
           </a:p>
           <a:p xmlns:a="http://schemas.openxmlformats.org/drawingml/2006/main">
@@ -1569,7 +1444,7 @@
           </a:p>
           <a:p xmlns:a="http://schemas.openxmlformats.org/drawingml/2006/main">
             <a:r>
-              <a:t>Key takeaway for the assessor: low error alone is insufficient when the practical question includes prioritising where observed fire outcomes occur.</a:t>
+              <a:t>On the frozen final temporal test, the nine-feature hurdle improved all-row MAE and Capture@20% versus the historical-recurrence baseline, while RMSE was essentially unchanged and positive-target error was slightly worse.</a:t>
             </a:r>
           </a:p>
           <a:p xmlns:a="http://schemas.openxmlformats.org/drawingml/2006/main">
@@ -1579,31 +1454,6 @@
           </a:p>
           <a:p xmlns:a="http://schemas.openxmlformats.org/drawingml/2006/main">
             <a:r>
-              <a:t>Methodological nuance: Capture@20% is a ranking diagnostic for the attempted regression models. It is not an accuracy score for the final historical bands.</a:t>
-            </a:r>
-          </a:p>
-          <a:p xmlns:a="http://schemas.openxmlformats.org/drawingml/2006/main">
-            <a:r>
-              <a:t/>
-            </a:r>
-          </a:p>
-          <a:p xmlns:a="http://schemas.openxmlformats.org/drawingml/2006/main">
-            <a:r>
-              <a:t>Likely assessor question and answer</a:t>
-            </a:r>
-          </a:p>
-          <a:p xmlns:a="http://schemas.openxmlformats.org/drawingml/2006/main">
-            <a:r>
-              <a:t>Why not accept the zero reference because it has the lowest MAE? It predicts no meaningful variation and captures only 11.38% of positive targets in the top-ranked fifth.</a:t>
-            </a:r>
-          </a:p>
-          <a:p xmlns:a="http://schemas.openxmlformats.org/drawingml/2006/main">
-            <a:r>
-              <a:t/>
-            </a:r>
-          </a:p>
-          <a:p xmlns:a="http://schemas.openxmlformats.org/drawingml/2006/main">
-            <a:r>
               <a:t>[Sources]</a:t>
             </a:r>
           </a:p>
@@ -1614,7 +1464,7 @@
           </a:p>
           <a:p xmlns:a="http://schemas.openxmlformats.org/drawingml/2006/main">
             <a:r>
-              <a:t>- reports/validation/train_validation_model_selection.md</a:t>
+              <a:t>- reports/validation/final_temporal_test_2022_2024.md</a:t>
             </a:r>
           </a:p>
           <a:p xmlns:a="http://schemas.openxmlformats.org/drawingml/2006/main">
@@ -1689,7 +1539,7 @@
           <a:lstStyle xmlns:a="http://schemas.openxmlformats.org/drawingml/2006/main"/>
           <a:p xmlns:a="http://schemas.openxmlformats.org/drawingml/2006/main">
             <a:r>
-              <a:t>This chart shows the validation-only evidence for the zero reference, the historical-fire baseline, Random Forest, and Tweedie. Historical recurrence captured 55.88% of positive-target rows in the top-ranked 20%, compared with 49.46% for Tweedie and 28.62% for Random Forest. Random Forest reduced MAE but worsened RMSE and ranking; Tweedie also failed the requirement for lower RMSE and non-inferior capture. Neither candidate passed the predefined gate, so no model advanced to final testing.</a:t>
+              <a:t>The figure compares the frozen historical-recurrence baseline with the frozen nine-feature hurdle on untouched predictor years T=2022–2024. Overall MAE improved from 0.0292 to 0.0214 and Capture@20% improved from 48.2% to 50.0%. RMSE was essentially unchanged at about 0.111. The model underpredicted the unusually high observed mean in T=2024, so annual estimates must be interpreted cautiously.</a:t>
             </a:r>
           </a:p>
           <a:p xmlns:a="http://schemas.openxmlformats.org/drawingml/2006/main">
@@ -1699,7 +1549,7 @@
           </a:p>
           <a:p xmlns:a="http://schemas.openxmlformats.org/drawingml/2006/main">
             <a:r>
-              <a:t>Key takeaway for the assessor: I closed the predictive gate rather than selecting a model on one favourable metric.</a:t>
+              <a:t>Key takeaway: the hurdle adds useful comparative variation, but it is not a probability or property-level prediction.</a:t>
             </a:r>
           </a:p>
           <a:p xmlns:a="http://schemas.openxmlformats.org/drawingml/2006/main">
@@ -1709,31 +1559,6 @@
           </a:p>
           <a:p xmlns:a="http://schemas.openxmlformats.org/drawingml/2006/main">
             <a:r>
-              <a:t>Methodological nuance: MAE and RMSE apply to the attempted regression outputs. Historical recurrence was retained as descriptive evidence, not re-labelled as a predictive model.</a:t>
-            </a:r>
-          </a:p>
-          <a:p xmlns:a="http://schemas.openxmlformats.org/drawingml/2006/main">
-            <a:r>
-              <a:t/>
-            </a:r>
-          </a:p>
-          <a:p xmlns:a="http://schemas.openxmlformats.org/drawingml/2006/main">
-            <a:r>
-              <a:t>Likely assessor question and answer</a:t>
-            </a:r>
-          </a:p>
-          <a:p xmlns:a="http://schemas.openxmlformats.org/drawingml/2006/main">
-            <a:r>
-              <a:t>What was the acceptance rule? At least 2% lower validation MAE and RMSE than the historical baseline, with Capture@20% no lower.</a:t>
-            </a:r>
-          </a:p>
-          <a:p xmlns:a="http://schemas.openxmlformats.org/drawingml/2006/main">
-            <a:r>
-              <a:t/>
-            </a:r>
-          </a:p>
-          <a:p xmlns:a="http://schemas.openxmlformats.org/drawingml/2006/main">
-            <a:r>
               <a:t>[Sources]</a:t>
             </a:r>
           </a:p>
@@ -1744,12 +1569,17 @@
           </a:p>
           <a:p xmlns:a="http://schemas.openxmlformats.org/drawingml/2006/main">
             <a:r>
-              <a:t>- reports/validation/train_validation_model_selection.md</a:t>
-            </a:r>
-          </a:p>
-          <a:p xmlns:a="http://schemas.openxmlformats.org/drawingml/2006/main">
-            <a:r>
-              <a:t>- reports/validation/train_validation_model_selection.json</a:t>
+              <a:t>- data/processed/extended_model_selection_2010_2021/final_temporal_test_metrics.json</a:t>
+            </a:r>
+          </a:p>
+          <a:p xmlns:a="http://schemas.openxmlformats.org/drawingml/2006/main">
+            <a:r>
+              <a:t>- reports/validation/final_temporal_test_2022_2024.md</a:t>
+            </a:r>
+          </a:p>
+          <a:p xmlns:a="http://schemas.openxmlformats.org/drawingml/2006/main">
+            <a:r>
+              <a:t>- reports/validation/model_final_decision.md</a:t>
             </a:r>
           </a:p>
         </p:txBody>
@@ -2207,7 +2037,7 @@
   </p:cSld>
   <p:clrMap bg1="lt1" tx1="dk1" bg2="lt2" tx2="dk2" accent1="accent1" accent2="accent2" accent3="accent3" accent4="accent4" accent5="accent5" accent6="accent6" hlink="hlink" folHlink="folHlink"/>
   <p:sldLayoutIdLst>
-    <p:sldLayoutId xmlns:r="http://schemas.openxmlformats.org/officeDocument/2006/relationships" id="2147483649" r:id="Rab628e580b53471b"/>
+    <p:sldLayoutId xmlns:r="http://schemas.openxmlformats.org/officeDocument/2006/relationships" id="2147483649" r:id="Rd58772ef7a0140cf"/>
   </p:sldLayoutIdLst>
   <p:txStyles>
     <p:titleStyle>
@@ -2819,6 +2649,7 @@
           <a:lstStyle xmlns:a="http://schemas.openxmlformats.org/drawingml/2006/main"/>
           <a:p xmlns:a="http://schemas.openxmlformats.org/drawingml/2006/main">
             <a:pPr algn="l">
+              <a:buNone/>
               <a:defRPr sz="1650" b="1">
                 <a:solidFill>
                   <a:srgbClr val="0F5B5A"/>
@@ -2869,6 +2700,7 @@
           <a:lstStyle xmlns:a="http://schemas.openxmlformats.org/drawingml/2006/main"/>
           <a:p xmlns:a="http://schemas.openxmlformats.org/drawingml/2006/main">
             <a:pPr algn="l">
+              <a:buNone/>
               <a:defRPr sz="4950" b="1">
                 <a:solidFill>
                   <a:srgbClr val="20262B"/>
@@ -2952,6 +2784,7 @@
           <a:lstStyle xmlns:a="http://schemas.openxmlformats.org/drawingml/2006/main"/>
           <a:p xmlns:a="http://schemas.openxmlformats.org/drawingml/2006/main">
             <a:pPr algn="l">
+              <a:buNone/>
               <a:defRPr sz="2100" b="0">
                 <a:solidFill>
                   <a:srgbClr val="153F3E"/>
@@ -2964,7 +2797,7 @@
                   <a:srgbClr val="153F3E"/>
                 </a:solidFill>
               </a:rPr>
-              <a:t>A reproducible historical screening tool, not a property-level wildfire forecast.</a:t>
+              <a:t>Historical screening plus a validated annual comparative-exposure model—not a property-level safety forecast.</a:t>
             </a:r>
           </a:p>
         </p:txBody>
@@ -3002,6 +2835,7 @@
           <a:lstStyle xmlns:a="http://schemas.openxmlformats.org/drawingml/2006/main"/>
           <a:p xmlns:a="http://schemas.openxmlformats.org/drawingml/2006/main">
             <a:pPr algn="l">
+              <a:buNone/>
               <a:defRPr sz="1800" b="1">
                 <a:solidFill>
                   <a:srgbClr val="20262B"/>
@@ -3052,6 +2886,7 @@
           <a:lstStyle xmlns:a="http://schemas.openxmlformats.org/drawingml/2006/main"/>
           <a:p xmlns:a="http://schemas.openxmlformats.org/drawingml/2006/main">
             <a:pPr algn="l">
+              <a:buNone/>
               <a:defRPr sz="1425" b="0">
                 <a:solidFill>
                   <a:srgbClr val="56646B"/>
@@ -3064,7 +2899,7 @@
                   <a:srgbClr val="56646B"/>
                 </a:solidFill>
               </a:rPr>
-              <a:t>5 August 2026</a:t>
+              <a:t>6 August 2026</a:t>
             </a:r>
           </a:p>
         </p:txBody>
@@ -3131,6 +2966,7 @@
           <a:lstStyle xmlns:a="http://schemas.openxmlformats.org/drawingml/2006/main"/>
           <a:p xmlns:a="http://schemas.openxmlformats.org/drawingml/2006/main">
             <a:pPr algn="l">
+              <a:buNone/>
               <a:defRPr sz="3600" b="1">
                 <a:solidFill>
                   <a:srgbClr val="20262B"/>
@@ -3214,6 +3050,7 @@
           <a:lstStyle xmlns:a="http://schemas.openxmlformats.org/drawingml/2006/main"/>
           <a:p xmlns:a="http://schemas.openxmlformats.org/drawingml/2006/main">
             <a:pPr algn="l">
+              <a:buNone/>
               <a:defRPr sz="1500" b="0">
                 <a:solidFill>
                   <a:srgbClr val="56646B"/>
@@ -3264,6 +3101,7 @@
           <a:lstStyle xmlns:a="http://schemas.openxmlformats.org/drawingml/2006/main"/>
           <a:p xmlns:a="http://schemas.openxmlformats.org/drawingml/2006/main">
             <a:pPr algn="r">
+              <a:buNone/>
               <a:defRPr sz="1200" b="0">
                 <a:solidFill>
                   <a:srgbClr val="56646B"/>
@@ -3283,14 +3121,14 @@
       </p:sp>
       <p:pic>
         <p:nvPicPr>
-          <p:cNvPr id="10" name=""/>
+          <p:cNvPr id="12" name=""/>
           <p:cNvPicPr>
             <a:picLocks xmlns:a="http://schemas.openxmlformats.org/drawingml/2006/main" noChangeAspect="1"/>
           </p:cNvPicPr>
           <p:nvPr/>
         </p:nvPicPr>
         <p:blipFill>
-          <a:blip xmlns:r="http://schemas.openxmlformats.org/officeDocument/2006/relationships" xmlns:a="http://schemas.openxmlformats.org/drawingml/2006/main" r:embed="R09cf8bd4d60944e3"/>
+          <a:blip xmlns:r="http://schemas.openxmlformats.org/officeDocument/2006/relationships" xmlns:a="http://schemas.openxmlformats.org/drawingml/2006/main" r:embed="R1edb9f408cb64e36"/>
           <a:stretch xmlns:a="http://schemas.openxmlformats.org/drawingml/2006/main"/>
         </p:blipFill>
         <p:spPr>
@@ -3365,6 +3203,7 @@
           <a:lstStyle xmlns:a="http://schemas.openxmlformats.org/drawingml/2006/main"/>
           <a:p xmlns:a="http://schemas.openxmlformats.org/drawingml/2006/main">
             <a:pPr algn="l">
+              <a:buNone/>
               <a:defRPr sz="3600" b="1">
                 <a:solidFill>
                   <a:srgbClr val="20262B"/>
@@ -3448,6 +3287,7 @@
           <a:lstStyle xmlns:a="http://schemas.openxmlformats.org/drawingml/2006/main"/>
           <a:p xmlns:a="http://schemas.openxmlformats.org/drawingml/2006/main">
             <a:pPr algn="r">
+              <a:buNone/>
               <a:defRPr sz="1200" b="0">
                 <a:solidFill>
                   <a:srgbClr val="56646B"/>
@@ -3467,14 +3307,14 @@
       </p:sp>
       <p:pic>
         <p:nvPicPr>
-          <p:cNvPr id="21" name=""/>
+          <p:cNvPr id="23" name=""/>
           <p:cNvPicPr>
             <a:picLocks xmlns:a="http://schemas.openxmlformats.org/drawingml/2006/main" noChangeAspect="1"/>
           </p:cNvPicPr>
           <p:nvPr/>
         </p:nvPicPr>
         <p:blipFill>
-          <a:blip xmlns:r="http://schemas.openxmlformats.org/officeDocument/2006/relationships" xmlns:a="http://schemas.openxmlformats.org/drawingml/2006/main" r:embed="Rfeba6245205d40d2"/>
+          <a:blip xmlns:r="http://schemas.openxmlformats.org/officeDocument/2006/relationships" xmlns:a="http://schemas.openxmlformats.org/drawingml/2006/main" r:embed="R0f1c8c8d332c4a16"/>
           <a:stretch xmlns:a="http://schemas.openxmlformats.org/drawingml/2006/main"/>
         </p:blipFill>
         <p:spPr>
@@ -3520,6 +3360,7 @@
           <a:lstStyle xmlns:a="http://schemas.openxmlformats.org/drawingml/2006/main"/>
           <a:p xmlns:a="http://schemas.openxmlformats.org/drawingml/2006/main">
             <a:pPr algn="l">
+              <a:buNone/>
               <a:defRPr sz="4500" b="1">
                 <a:solidFill>
                   <a:srgbClr val="153F3E"/>
@@ -3570,6 +3411,7 @@
           <a:lstStyle xmlns:a="http://schemas.openxmlformats.org/drawingml/2006/main"/>
           <a:p xmlns:a="http://schemas.openxmlformats.org/drawingml/2006/main">
             <a:pPr algn="l">
+              <a:buNone/>
               <a:defRPr sz="1575" b="0">
                 <a:solidFill>
                   <a:srgbClr val="56646B"/>
@@ -3653,6 +3495,7 @@
           <a:lstStyle xmlns:a="http://schemas.openxmlformats.org/drawingml/2006/main"/>
           <a:p xmlns:a="http://schemas.openxmlformats.org/drawingml/2006/main">
             <a:pPr algn="l">
+              <a:buNone/>
               <a:defRPr sz="1800" b="1">
                 <a:solidFill>
                   <a:srgbClr val="0F5B5A"/>
@@ -3703,6 +3546,7 @@
           <a:lstStyle xmlns:a="http://schemas.openxmlformats.org/drawingml/2006/main"/>
           <a:p xmlns:a="http://schemas.openxmlformats.org/drawingml/2006/main">
             <a:pPr algn="l">
+              <a:buNone/>
               <a:defRPr sz="1275" b="0">
                 <a:solidFill>
                   <a:srgbClr val="20262B"/>
@@ -3753,6 +3597,7 @@
           <a:lstStyle xmlns:a="http://schemas.openxmlformats.org/drawingml/2006/main"/>
           <a:p xmlns:a="http://schemas.openxmlformats.org/drawingml/2006/main">
             <a:pPr algn="l">
+              <a:buNone/>
               <a:defRPr sz="1800" b="1">
                 <a:solidFill>
                   <a:srgbClr val="0F5B5A"/>
@@ -3803,6 +3648,7 @@
           <a:lstStyle xmlns:a="http://schemas.openxmlformats.org/drawingml/2006/main"/>
           <a:p xmlns:a="http://schemas.openxmlformats.org/drawingml/2006/main">
             <a:pPr algn="l">
+              <a:buNone/>
               <a:defRPr sz="1275" b="0">
                 <a:solidFill>
                   <a:srgbClr val="20262B"/>
@@ -3853,6 +3699,7 @@
           <a:lstStyle xmlns:a="http://schemas.openxmlformats.org/drawingml/2006/main"/>
           <a:p xmlns:a="http://schemas.openxmlformats.org/drawingml/2006/main">
             <a:pPr algn="l">
+              <a:buNone/>
               <a:defRPr sz="1800" b="1">
                 <a:solidFill>
                   <a:srgbClr val="0F5B5A"/>
@@ -3903,6 +3750,7 @@
           <a:lstStyle xmlns:a="http://schemas.openxmlformats.org/drawingml/2006/main"/>
           <a:p xmlns:a="http://schemas.openxmlformats.org/drawingml/2006/main">
             <a:pPr algn="l">
+              <a:buNone/>
               <a:defRPr sz="1275" b="0">
                 <a:solidFill>
                   <a:srgbClr val="20262B"/>
@@ -3953,6 +3801,7 @@
           <a:lstStyle xmlns:a="http://schemas.openxmlformats.org/drawingml/2006/main"/>
           <a:p xmlns:a="http://schemas.openxmlformats.org/drawingml/2006/main">
             <a:pPr algn="l">
+              <a:buNone/>
               <a:defRPr sz="1800" b="1">
                 <a:solidFill>
                   <a:srgbClr val="0F5B5A"/>
@@ -4003,6 +3852,7 @@
           <a:lstStyle xmlns:a="http://schemas.openxmlformats.org/drawingml/2006/main"/>
           <a:p xmlns:a="http://schemas.openxmlformats.org/drawingml/2006/main">
             <a:pPr algn="l">
+              <a:buNone/>
               <a:defRPr sz="1275" b="0">
                 <a:solidFill>
                   <a:srgbClr val="20262B"/>
@@ -4088,6 +3938,7 @@
           <a:lstStyle xmlns:a="http://schemas.openxmlformats.org/drawingml/2006/main"/>
           <a:p xmlns:a="http://schemas.openxmlformats.org/drawingml/2006/main">
             <a:pPr algn="ctr">
+              <a:buNone/>
               <a:defRPr sz="1725" b="1">
                 <a:solidFill>
                   <a:srgbClr val="9B2226"/>
@@ -4167,6 +4018,7 @@
           <a:lstStyle xmlns:a="http://schemas.openxmlformats.org/drawingml/2006/main"/>
           <a:p xmlns:a="http://schemas.openxmlformats.org/drawingml/2006/main">
             <a:pPr algn="l">
+              <a:buNone/>
               <a:defRPr sz="3600" b="1">
                 <a:solidFill>
                   <a:srgbClr val="20262B"/>
@@ -4179,7 +4031,7 @@
                   <a:srgbClr val="20262B"/>
                 </a:solidFill>
               </a:rPr>
-              <a:t>The project delivers screening with explicit limits</a:t>
+              <a:t>Two complementary outputs, explicit limits</a:t>
             </a:r>
           </a:p>
         </p:txBody>
@@ -4250,6 +4102,7 @@
           <a:lstStyle xmlns:a="http://schemas.openxmlformats.org/drawingml/2006/main"/>
           <a:p xmlns:a="http://schemas.openxmlformats.org/drawingml/2006/main">
             <a:pPr algn="r">
+              <a:buNone/>
               <a:defRPr sz="1200" b="0">
                 <a:solidFill>
                   <a:srgbClr val="56646B"/>
@@ -4300,6 +4153,7 @@
           <a:lstStyle xmlns:a="http://schemas.openxmlformats.org/drawingml/2006/main"/>
           <a:p xmlns:a="http://schemas.openxmlformats.org/drawingml/2006/main">
             <a:pPr algn="l">
+              <a:buNone/>
               <a:defRPr sz="1575" b="1">
                 <a:solidFill>
                   <a:srgbClr val="0F5B5A"/>
@@ -4385,6 +4239,7 @@
           <a:lstStyle xmlns:a="http://schemas.openxmlformats.org/drawingml/2006/main"/>
           <a:p xmlns:a="http://schemas.openxmlformats.org/drawingml/2006/main">
             <a:pPr algn="ctr">
+              <a:buNone/>
               <a:defRPr sz="1350" b="1">
                 <a:solidFill>
                   <a:srgbClr val="20262B"/>
@@ -4402,6 +4257,7 @@
           </a:p>
           <a:p xmlns:a="http://schemas.openxmlformats.org/drawingml/2006/main">
             <a:pPr algn="ctr">
+              <a:buNone/>
               <a:defRPr sz="1350" b="1">
                 <a:solidFill>
                   <a:srgbClr val="20262B"/>
@@ -4419,6 +4275,7 @@
           </a:p>
           <a:p xmlns:a="http://schemas.openxmlformats.org/drawingml/2006/main">
             <a:pPr algn="ctr">
+              <a:buNone/>
               <a:defRPr sz="1350" b="1">
                 <a:solidFill>
                   <a:srgbClr val="20262B"/>
@@ -4537,6 +4394,7 @@
           <a:lstStyle xmlns:a="http://schemas.openxmlformats.org/drawingml/2006/main"/>
           <a:p xmlns:a="http://schemas.openxmlformats.org/drawingml/2006/main">
             <a:pPr algn="ctr">
+              <a:buNone/>
               <a:defRPr sz="1350" b="1">
                 <a:solidFill>
                   <a:srgbClr val="20262B"/>
@@ -4554,6 +4412,7 @@
           </a:p>
           <a:p xmlns:a="http://schemas.openxmlformats.org/drawingml/2006/main">
             <a:pPr algn="ctr">
+              <a:buNone/>
               <a:defRPr sz="1350" b="1">
                 <a:solidFill>
                   <a:srgbClr val="20262B"/>
@@ -4571,6 +4430,7 @@
           </a:p>
           <a:p xmlns:a="http://schemas.openxmlformats.org/drawingml/2006/main">
             <a:pPr algn="ctr">
+              <a:buNone/>
               <a:defRPr sz="1350" b="1">
                 <a:solidFill>
                   <a:srgbClr val="20262B"/>
@@ -4689,6 +4549,7 @@
           <a:lstStyle xmlns:a="http://schemas.openxmlformats.org/drawingml/2006/main"/>
           <a:p xmlns:a="http://schemas.openxmlformats.org/drawingml/2006/main">
             <a:pPr algn="ctr">
+              <a:buNone/>
               <a:defRPr sz="1350" b="1">
                 <a:solidFill>
                   <a:srgbClr val="20262B"/>
@@ -4706,6 +4567,7 @@
           </a:p>
           <a:p xmlns:a="http://schemas.openxmlformats.org/drawingml/2006/main">
             <a:pPr algn="ctr">
+              <a:buNone/>
               <a:defRPr sz="1350" b="1">
                 <a:solidFill>
                   <a:srgbClr val="20262B"/>
@@ -4756,6 +4618,7 @@
           <a:lstStyle xmlns:a="http://schemas.openxmlformats.org/drawingml/2006/main"/>
           <a:p xmlns:a="http://schemas.openxmlformats.org/drawingml/2006/main">
             <a:pPr algn="ctr">
+              <a:buNone/>
               <a:defRPr sz="1425" b="1">
                 <a:solidFill>
                   <a:srgbClr val="153F3E"/>
@@ -4841,6 +4704,7 @@
           <a:lstStyle xmlns:a="http://schemas.openxmlformats.org/drawingml/2006/main"/>
           <a:p xmlns:a="http://schemas.openxmlformats.org/drawingml/2006/main">
             <a:pPr algn="ctr">
+              <a:buNone/>
               <a:defRPr sz="1200" b="1">
                 <a:solidFill>
                   <a:srgbClr val="9B2226"/>
@@ -4853,7 +4717,7 @@
                   <a:srgbClr val="9B2226"/>
                 </a:solidFill>
               </a:rPr>
-              <a:t>Not a next-year forecast, property-level safety guarantee, wildfire-risk probability, or purchase recommendation.</a:t>
+              <a:t>Not a property-level safety guarantee, wildfire-risk probability, insurance estimate, or purchase recommendation.</a:t>
             </a:r>
           </a:p>
         </p:txBody>
@@ -4891,6 +4755,7 @@
           <a:lstStyle xmlns:a="http://schemas.openxmlformats.org/drawingml/2006/main"/>
           <a:p xmlns:a="http://schemas.openxmlformats.org/drawingml/2006/main">
             <a:pPr algn="l">
+              <a:buNone/>
               <a:defRPr sz="1650" b="1">
                 <a:solidFill>
                   <a:srgbClr val="0F5B5A"/>
@@ -4941,6 +4806,7 @@
           <a:lstStyle xmlns:a="http://schemas.openxmlformats.org/drawingml/2006/main"/>
           <a:p xmlns:a="http://schemas.openxmlformats.org/drawingml/2006/main">
             <a:pPr algn="l">
+              <a:buNone/>
               <a:defRPr sz="2100" b="1">
                 <a:solidFill>
                   <a:srgbClr val="0F5B5A"/>
@@ -4991,6 +4857,7 @@
           <a:lstStyle xmlns:a="http://schemas.openxmlformats.org/drawingml/2006/main"/>
           <a:p xmlns:a="http://schemas.openxmlformats.org/drawingml/2006/main">
             <a:pPr algn="l">
+              <a:buNone/>
               <a:defRPr sz="1575" b="0">
                 <a:solidFill>
                   <a:srgbClr val="20262B"/>
@@ -5003,7 +4870,7 @@
                   <a:srgbClr val="20262B"/>
                 </a:solidFill>
               </a:rPr>
-              <a:t>Historical recurrence was the strongest validated evidence for comparative screening.</a:t>
+              <a:t>Historical recurrence remains the transparent reference and a separate observed-history screening layer.</a:t>
             </a:r>
           </a:p>
         </p:txBody>
@@ -5041,6 +4908,7 @@
           <a:lstStyle xmlns:a="http://schemas.openxmlformats.org/drawingml/2006/main"/>
           <a:p xmlns:a="http://schemas.openxmlformats.org/drawingml/2006/main">
             <a:pPr algn="l">
+              <a:buNone/>
               <a:defRPr sz="2100" b="1">
                 <a:solidFill>
                   <a:srgbClr val="0F5B5A"/>
@@ -5091,6 +4959,7 @@
           <a:lstStyle xmlns:a="http://schemas.openxmlformats.org/drawingml/2006/main"/>
           <a:p xmlns:a="http://schemas.openxmlformats.org/drawingml/2006/main">
             <a:pPr algn="l">
+              <a:buNone/>
               <a:defRPr sz="1575" b="0">
                 <a:solidFill>
                   <a:srgbClr val="20262B"/>
@@ -5103,7 +4972,7 @@
                   <a:srgbClr val="20262B"/>
                 </a:solidFill>
               </a:rPr>
-              <a:t>Random Forest and Tweedie were not selected because they did not improve sufficiently on validation.</a:t>
+              <a:t>The frozen nine-feature hurdle improved final-test MAE and ranking, with similar RMSE and cautious high-burn calibration.</a:t>
             </a:r>
           </a:p>
         </p:txBody>
@@ -5141,6 +5010,7 @@
           <a:lstStyle xmlns:a="http://schemas.openxmlformats.org/drawingml/2006/main"/>
           <a:p xmlns:a="http://schemas.openxmlformats.org/drawingml/2006/main">
             <a:pPr algn="l">
+              <a:buNone/>
               <a:defRPr sz="2100" b="1">
                 <a:solidFill>
                   <a:srgbClr val="0F5B5A"/>
@@ -5191,6 +5061,7 @@
           <a:lstStyle xmlns:a="http://schemas.openxmlformats.org/drawingml/2006/main"/>
           <a:p xmlns:a="http://schemas.openxmlformats.org/drawingml/2006/main">
             <a:pPr algn="l">
+              <a:buNone/>
               <a:defRPr sz="1575" b="0">
                 <a:solidFill>
                   <a:srgbClr val="20262B"/>
@@ -5203,7 +5074,7 @@
                   <a:srgbClr val="20262B"/>
                 </a:solidFill>
               </a:rPr>
-              <a:t>The result is a reproducible, inspectable national GIS screening workflow.</a:t>
+              <a:t>The result combines an inspectable historical GIS layer with a reproducible annual comparative-estimate workflow.</a:t>
             </a:r>
           </a:p>
         </p:txBody>
@@ -5276,6 +5147,7 @@
           <a:lstStyle xmlns:a="http://schemas.openxmlformats.org/drawingml/2006/main"/>
           <a:p xmlns:a="http://schemas.openxmlformats.org/drawingml/2006/main">
             <a:pPr algn="l">
+              <a:buNone/>
               <a:defRPr sz="1575" b="1">
                 <a:solidFill>
                   <a:srgbClr val="0F5B5A"/>
@@ -5326,6 +5198,7 @@
           <a:lstStyle xmlns:a="http://schemas.openxmlformats.org/drawingml/2006/main"/>
           <a:p xmlns:a="http://schemas.openxmlformats.org/drawingml/2006/main">
             <a:pPr algn="l">
+              <a:buNone/>
               <a:defRPr sz="1425" b="0">
                 <a:solidFill>
                   <a:srgbClr val="20262B"/>
@@ -5376,6 +5249,7 @@
           <a:lstStyle xmlns:a="http://schemas.openxmlformats.org/drawingml/2006/main"/>
           <a:p xmlns:a="http://schemas.openxmlformats.org/drawingml/2006/main">
             <a:pPr algn="l">
+              <a:buNone/>
               <a:defRPr sz="1350" b="1">
                 <a:solidFill>
                   <a:srgbClr val="153F3E"/>
@@ -5455,6 +5329,7 @@
           <a:lstStyle xmlns:a="http://schemas.openxmlformats.org/drawingml/2006/main"/>
           <a:p xmlns:a="http://schemas.openxmlformats.org/drawingml/2006/main">
             <a:pPr algn="l">
+              <a:buNone/>
               <a:defRPr sz="3600" b="1">
                 <a:solidFill>
                   <a:srgbClr val="20262B"/>
@@ -5538,6 +5413,7 @@
           <a:lstStyle xmlns:a="http://schemas.openxmlformats.org/drawingml/2006/main"/>
           <a:p xmlns:a="http://schemas.openxmlformats.org/drawingml/2006/main">
             <a:pPr algn="r">
+              <a:buNone/>
               <a:defRPr sz="1200" b="0">
                 <a:solidFill>
                   <a:srgbClr val="56646B"/>
@@ -5588,6 +5464,7 @@
           <a:lstStyle xmlns:a="http://schemas.openxmlformats.org/drawingml/2006/main"/>
           <a:p xmlns:a="http://schemas.openxmlformats.org/drawingml/2006/main">
             <a:pPr algn="l">
+              <a:buNone/>
               <a:defRPr sz="1650" b="1">
                 <a:solidFill>
                   <a:srgbClr val="153F3E"/>
@@ -5638,6 +5515,7 @@
           <a:lstStyle xmlns:a="http://schemas.openxmlformats.org/drawingml/2006/main"/>
           <a:p xmlns:a="http://schemas.openxmlformats.org/drawingml/2006/main">
             <a:pPr algn="l">
+              <a:buNone/>
               <a:defRPr sz="1425" b="0">
                 <a:solidFill>
                   <a:srgbClr val="20262B"/>
@@ -5721,6 +5599,7 @@
           <a:lstStyle xmlns:a="http://schemas.openxmlformats.org/drawingml/2006/main"/>
           <a:p xmlns:a="http://schemas.openxmlformats.org/drawingml/2006/main">
             <a:pPr algn="l">
+              <a:buNone/>
               <a:defRPr sz="1650" b="1">
                 <a:solidFill>
                   <a:srgbClr val="153F3E"/>
@@ -5771,6 +5650,7 @@
           <a:lstStyle xmlns:a="http://schemas.openxmlformats.org/drawingml/2006/main"/>
           <a:p xmlns:a="http://schemas.openxmlformats.org/drawingml/2006/main">
             <a:pPr algn="l">
+              <a:buNone/>
               <a:defRPr sz="1425" b="0">
                 <a:solidFill>
                   <a:srgbClr val="20262B"/>
@@ -5783,7 +5663,7 @@
                   <a:srgbClr val="20262B"/>
                 </a:solidFill>
               </a:rPr>
-              <a:t>The seven-feature regressions did not beat the historical-recurrence reference sufficiently on validation.</a:t>
+              <a:t>The frozen nine-feature hurdle improved MAE and ranking versus recurrence, but not RMSE, on the final temporal test.</a:t>
             </a:r>
           </a:p>
         </p:txBody>
@@ -5854,6 +5734,7 @@
           <a:lstStyle xmlns:a="http://schemas.openxmlformats.org/drawingml/2006/main"/>
           <a:p xmlns:a="http://schemas.openxmlformats.org/drawingml/2006/main">
             <a:pPr algn="l">
+              <a:buNone/>
               <a:defRPr sz="1650" b="1">
                 <a:solidFill>
                   <a:srgbClr val="153F3E"/>
@@ -5904,6 +5785,7 @@
           <a:lstStyle xmlns:a="http://schemas.openxmlformats.org/drawingml/2006/main"/>
           <a:p xmlns:a="http://schemas.openxmlformats.org/drawingml/2006/main">
             <a:pPr algn="l">
+              <a:buNone/>
               <a:defRPr sz="1425" b="0">
                 <a:solidFill>
                   <a:srgbClr val="20262B"/>
@@ -5916,7 +5798,7 @@
                   <a:srgbClr val="20262B"/>
                 </a:solidFill>
               </a:rPr>
-              <a:t>They were appropriate for an initial reproducible experiment, but insufficient for an accepted next-year model.</a:t>
+              <a:t>Nine governed features supported a useful comparative model; calibration remains weak for unusually high-burn years.</a:t>
             </a:r>
           </a:p>
         </p:txBody>
@@ -5987,6 +5869,7 @@
           <a:lstStyle xmlns:a="http://schemas.openxmlformats.org/drawingml/2006/main"/>
           <a:p xmlns:a="http://schemas.openxmlformats.org/drawingml/2006/main">
             <a:pPr algn="l">
+              <a:buNone/>
               <a:defRPr sz="1650" b="1">
                 <a:solidFill>
                   <a:srgbClr val="153F3E"/>
@@ -6037,6 +5920,7 @@
           <a:lstStyle xmlns:a="http://schemas.openxmlformats.org/drawingml/2006/main"/>
           <a:p xmlns:a="http://schemas.openxmlformats.org/drawingml/2006/main">
             <a:pPr algn="l">
+              <a:buNone/>
               <a:defRPr sz="1425" b="0">
                 <a:solidFill>
                   <a:srgbClr val="20262B"/>
@@ -6049,7 +5933,7 @@
                   <a:srgbClr val="20262B"/>
                 </a:solidFill>
               </a:rPr>
-              <a:t>Yes as a reproducible GIS screening workflow; no as an accepted next-year prediction project.</a:t>
+              <a:t>Yes: it produced validated historical screening and a tested annual comparative-estimate workflow with explicit limits.</a:t>
             </a:r>
           </a:p>
         </p:txBody>
@@ -6120,6 +6004,7 @@
           <a:lstStyle xmlns:a="http://schemas.openxmlformats.org/drawingml/2006/main"/>
           <a:p xmlns:a="http://schemas.openxmlformats.org/drawingml/2006/main">
             <a:pPr algn="l">
+              <a:buNone/>
               <a:defRPr sz="1650" b="1">
                 <a:solidFill>
                   <a:srgbClr val="153F3E"/>
@@ -6170,6 +6055,7 @@
           <a:lstStyle xmlns:a="http://schemas.openxmlformats.org/drawingml/2006/main"/>
           <a:p xmlns:a="http://schemas.openxmlformats.org/drawingml/2006/main">
             <a:pPr algn="l">
+              <a:buNone/>
               <a:defRPr sz="1425" b="0">
                 <a:solidFill>
                   <a:srgbClr val="20262B"/>
@@ -6253,6 +6139,7 @@
           <a:lstStyle xmlns:a="http://schemas.openxmlformats.org/drawingml/2006/main"/>
           <a:p xmlns:a="http://schemas.openxmlformats.org/drawingml/2006/main">
             <a:pPr algn="l">
+              <a:buNone/>
               <a:defRPr sz="1650" b="1">
                 <a:solidFill>
                   <a:srgbClr val="153F3E"/>
@@ -6303,6 +6190,7 @@
           <a:lstStyle xmlns:a="http://schemas.openxmlformats.org/drawingml/2006/main"/>
           <a:p xmlns:a="http://schemas.openxmlformats.org/drawingml/2006/main">
             <a:pPr algn="l">
+              <a:buNone/>
               <a:defRPr sz="1425" b="0">
                 <a:solidFill>
                   <a:srgbClr val="20262B"/>
@@ -6315,7 +6203,7 @@
                   <a:srgbClr val="20262B"/>
                 </a:solidFill>
               </a:rPr>
-              <a:t>It was the strongest validated comparative evidence and remains transparently interpretable.</a:t>
+              <a:t>It remains an interpretable observed-history reference, separate from the model's annual estimate.</a:t>
             </a:r>
           </a:p>
         </p:txBody>
@@ -6421,6 +6309,7 @@
           <a:lstStyle xmlns:a="http://schemas.openxmlformats.org/drawingml/2006/main"/>
           <a:p xmlns:a="http://schemas.openxmlformats.org/drawingml/2006/main">
             <a:pPr algn="ctr">
+              <a:buNone/>
               <a:defRPr sz="1500" b="1">
                 <a:solidFill>
                   <a:srgbClr val="153F3E"/>
@@ -6433,7 +6322,7 @@
                   <a:srgbClr val="153F3E"/>
                 </a:solidFill>
               </a:rPr>
-              <a:t>Central conclusion: no predictive model was selected; the final deliverable is historical comparative screening.</a:t>
+              <a:t>Central conclusion: retain both products—historical screening for context and the fixed hurdle for cautious annual comparison.</a:t>
             </a:r>
           </a:p>
         </p:txBody>
@@ -6500,6 +6389,7 @@
           <a:lstStyle xmlns:a="http://schemas.openxmlformats.org/drawingml/2006/main"/>
           <a:p xmlns:a="http://schemas.openxmlformats.org/drawingml/2006/main">
             <a:pPr algn="l">
+              <a:buNone/>
               <a:defRPr sz="3600" b="1">
                 <a:solidFill>
                   <a:srgbClr val="20262B"/>
@@ -6583,6 +6473,7 @@
           <a:lstStyle xmlns:a="http://schemas.openxmlformats.org/drawingml/2006/main"/>
           <a:p xmlns:a="http://schemas.openxmlformats.org/drawingml/2006/main">
             <a:pPr algn="r">
+              <a:buNone/>
               <a:defRPr sz="1200" b="0">
                 <a:solidFill>
                   <a:srgbClr val="56646B"/>
@@ -6633,6 +6524,7 @@
           <a:lstStyle xmlns:a="http://schemas.openxmlformats.org/drawingml/2006/main"/>
           <a:p xmlns:a="http://schemas.openxmlformats.org/drawingml/2006/main">
             <a:pPr algn="l">
+              <a:buNone/>
               <a:defRPr sz="2850" b="1">
                 <a:solidFill>
                   <a:srgbClr val="153F3E"/>
@@ -6683,6 +6575,7 @@
           <a:lstStyle xmlns:a="http://schemas.openxmlformats.org/drawingml/2006/main"/>
           <a:p xmlns:a="http://schemas.openxmlformats.org/drawingml/2006/main">
             <a:pPr algn="l">
+              <a:buNone/>
               <a:defRPr sz="1875" b="0">
                 <a:solidFill>
                   <a:srgbClr val="20262B"/>
@@ -6766,6 +6659,7 @@
           <a:lstStyle xmlns:a="http://schemas.openxmlformats.org/drawingml/2006/main"/>
           <a:p xmlns:a="http://schemas.openxmlformats.org/drawingml/2006/main">
             <a:pPr algn="l">
+              <a:buNone/>
               <a:defRPr sz="1575" b="1">
                 <a:solidFill>
                   <a:srgbClr val="0F5B5A"/>
@@ -6816,6 +6710,7 @@
           <a:lstStyle xmlns:a="http://schemas.openxmlformats.org/drawingml/2006/main"/>
           <a:p xmlns:a="http://schemas.openxmlformats.org/drawingml/2006/main">
             <a:pPr algn="l">
+              <a:buNone/>
               <a:defRPr sz="5100" b="1">
                 <a:solidFill>
                   <a:srgbClr val="20262B"/>
@@ -6866,6 +6761,7 @@
           <a:lstStyle xmlns:a="http://schemas.openxmlformats.org/drawingml/2006/main"/>
           <a:p xmlns:a="http://schemas.openxmlformats.org/drawingml/2006/main">
             <a:pPr algn="l">
+              <a:buNone/>
               <a:defRPr sz="1800" b="0">
                 <a:solidFill>
                   <a:srgbClr val="56646B"/>
@@ -6949,6 +6845,7 @@
           <a:lstStyle xmlns:a="http://schemas.openxmlformats.org/drawingml/2006/main"/>
           <a:p xmlns:a="http://schemas.openxmlformats.org/drawingml/2006/main">
             <a:pPr algn="l">
+              <a:buNone/>
               <a:defRPr sz="3900" b="1">
                 <a:solidFill>
                   <a:srgbClr val="153F3E"/>
@@ -6999,6 +6896,7 @@
           <a:lstStyle xmlns:a="http://schemas.openxmlformats.org/drawingml/2006/main"/>
           <a:p xmlns:a="http://schemas.openxmlformats.org/drawingml/2006/main">
             <a:pPr algn="l">
+              <a:buNone/>
               <a:defRPr sz="1650" b="0">
                 <a:solidFill>
                   <a:srgbClr val="56646B"/>
@@ -7084,6 +6982,7 @@
           <a:lstStyle xmlns:a="http://schemas.openxmlformats.org/drawingml/2006/main"/>
           <a:p xmlns:a="http://schemas.openxmlformats.org/drawingml/2006/main">
             <a:pPr algn="l">
+              <a:buNone/>
               <a:defRPr sz="1650" b="1">
                 <a:solidFill>
                   <a:srgbClr val="9B2226"/>
@@ -7163,6 +7062,7 @@
           <a:lstStyle xmlns:a="http://schemas.openxmlformats.org/drawingml/2006/main"/>
           <a:p xmlns:a="http://schemas.openxmlformats.org/drawingml/2006/main">
             <a:pPr algn="l">
+              <a:buNone/>
               <a:defRPr sz="3600" b="1">
                 <a:solidFill>
                   <a:srgbClr val="20262B"/>
@@ -7246,6 +7146,7 @@
           <a:lstStyle xmlns:a="http://schemas.openxmlformats.org/drawingml/2006/main"/>
           <a:p xmlns:a="http://schemas.openxmlformats.org/drawingml/2006/main">
             <a:pPr algn="l">
+              <a:buNone/>
               <a:defRPr sz="1500" b="0">
                 <a:solidFill>
                   <a:srgbClr val="56646B"/>
@@ -7296,6 +7197,7 @@
           <a:lstStyle xmlns:a="http://schemas.openxmlformats.org/drawingml/2006/main"/>
           <a:p xmlns:a="http://schemas.openxmlformats.org/drawingml/2006/main">
             <a:pPr algn="r">
+              <a:buNone/>
               <a:defRPr sz="1200" b="0">
                 <a:solidFill>
                   <a:srgbClr val="56646B"/>
@@ -7346,6 +7248,7 @@
           <a:lstStyle xmlns:a="http://schemas.openxmlformats.org/drawingml/2006/main"/>
           <a:p xmlns:a="http://schemas.openxmlformats.org/drawingml/2006/main">
             <a:pPr algn="l">
+              <a:buNone/>
               <a:defRPr sz="1875" b="1">
                 <a:solidFill>
                   <a:srgbClr val="0F5B5A"/>
@@ -7396,6 +7299,7 @@
           <a:lstStyle xmlns:a="http://schemas.openxmlformats.org/drawingml/2006/main"/>
           <a:p xmlns:a="http://schemas.openxmlformats.org/drawingml/2006/main">
             <a:pPr algn="l">
+              <a:buNone/>
               <a:defRPr sz="3225" b="1">
                 <a:solidFill>
                   <a:srgbClr val="20262B"/>
@@ -7446,6 +7350,7 @@
           <a:lstStyle xmlns:a="http://schemas.openxmlformats.org/drawingml/2006/main"/>
           <a:p xmlns:a="http://schemas.openxmlformats.org/drawingml/2006/main">
             <a:pPr algn="l">
+              <a:buNone/>
               <a:defRPr sz="1725" b="0">
                 <a:solidFill>
                   <a:srgbClr val="56646B"/>
@@ -7458,7 +7363,7 @@
                   <a:srgbClr val="56646B"/>
                 </a:solidFill>
               </a:rPr>
-              <a:t>89,112 cells × 10 observation years supplied enough records for a strict temporal ML experiment without narrowing the buyer's national decision.</a:t>
+              <a:t>89,112 cells and 15 labelled predictor years supported strict temporal evaluation before a fixed nine-feature model was refit through 2025 outcomes.</a:t>
             </a:r>
           </a:p>
         </p:txBody>
@@ -7529,6 +7434,7 @@
           <a:lstStyle xmlns:a="http://schemas.openxmlformats.org/drawingml/2006/main"/>
           <a:p xmlns:a="http://schemas.openxmlformats.org/drawingml/2006/main">
             <a:pPr algn="l">
+              <a:buNone/>
               <a:defRPr sz="2025" b="1">
                 <a:solidFill>
                   <a:srgbClr val="153F3E"/>
@@ -7579,6 +7485,7 @@
           <a:lstStyle xmlns:a="http://schemas.openxmlformats.org/drawingml/2006/main"/>
           <a:p xmlns:a="http://schemas.openxmlformats.org/drawingml/2006/main">
             <a:pPr algn="l">
+              <a:buNone/>
               <a:defRPr sz="1575" b="0">
                 <a:solidFill>
                   <a:srgbClr val="20262B"/>
@@ -7662,6 +7569,7 @@
           <a:lstStyle xmlns:a="http://schemas.openxmlformats.org/drawingml/2006/main"/>
           <a:p xmlns:a="http://schemas.openxmlformats.org/drawingml/2006/main">
             <a:pPr algn="l">
+              <a:buNone/>
               <a:defRPr sz="2025" b="1">
                 <a:solidFill>
                   <a:srgbClr val="153F3E"/>
@@ -7712,6 +7620,7 @@
           <a:lstStyle xmlns:a="http://schemas.openxmlformats.org/drawingml/2006/main"/>
           <a:p xmlns:a="http://schemas.openxmlformats.org/drawingml/2006/main">
             <a:pPr algn="l">
+              <a:buNone/>
               <a:defRPr sz="1575" b="0">
                 <a:solidFill>
                   <a:srgbClr val="20262B"/>
@@ -7795,6 +7704,7 @@
           <a:lstStyle xmlns:a="http://schemas.openxmlformats.org/drawingml/2006/main"/>
           <a:p xmlns:a="http://schemas.openxmlformats.org/drawingml/2006/main">
             <a:pPr algn="l">
+              <a:buNone/>
               <a:defRPr sz="2025" b="1">
                 <a:solidFill>
                   <a:srgbClr val="153F3E"/>
@@ -7845,6 +7755,7 @@
           <a:lstStyle xmlns:a="http://schemas.openxmlformats.org/drawingml/2006/main"/>
           <a:p xmlns:a="http://schemas.openxmlformats.org/drawingml/2006/main">
             <a:pPr algn="l">
+              <a:buNone/>
               <a:defRPr sz="1575" b="0">
                 <a:solidFill>
                   <a:srgbClr val="20262B"/>
@@ -7857,7 +7768,7 @@
                   <a:srgbClr val="20262B"/>
                 </a:solidFill>
               </a:rPr>
-              <a:t>Temporal train and validation periods support an honest predictive experiment.</a:t>
+              <a:t>Separated training, validation, and final-test years support an honest temporal evaluation.</a:t>
             </a:r>
           </a:p>
         </p:txBody>
@@ -7928,6 +7839,7 @@
           <a:lstStyle xmlns:a="http://schemas.openxmlformats.org/drawingml/2006/main"/>
           <a:p xmlns:a="http://schemas.openxmlformats.org/drawingml/2006/main">
             <a:pPr algn="l">
+              <a:buNone/>
               <a:defRPr sz="2025" b="1">
                 <a:solidFill>
                   <a:srgbClr val="153F3E"/>
@@ -7978,6 +7890,7 @@
           <a:lstStyle xmlns:a="http://schemas.openxmlformats.org/drawingml/2006/main"/>
           <a:p xmlns:a="http://schemas.openxmlformats.org/drawingml/2006/main">
             <a:pPr algn="l">
+              <a:buNone/>
               <a:defRPr sz="1575" b="0">
                 <a:solidFill>
                   <a:srgbClr val="20262B"/>
@@ -8028,6 +7941,7 @@
           <a:lstStyle xmlns:a="http://schemas.openxmlformats.org/drawingml/2006/main"/>
           <a:p xmlns:a="http://schemas.openxmlformats.org/drawingml/2006/main">
             <a:pPr algn="l">
+              <a:buNone/>
               <a:defRPr sz="1500" b="1">
                 <a:solidFill>
                   <a:srgbClr val="9B2226"/>
@@ -8107,6 +8021,7 @@
           <a:lstStyle xmlns:a="http://schemas.openxmlformats.org/drawingml/2006/main"/>
           <a:p xmlns:a="http://schemas.openxmlformats.org/drawingml/2006/main">
             <a:pPr algn="l">
+              <a:buNone/>
               <a:defRPr sz="3600" b="1">
                 <a:solidFill>
                   <a:srgbClr val="20262B"/>
@@ -8190,6 +8105,7 @@
           <a:lstStyle xmlns:a="http://schemas.openxmlformats.org/drawingml/2006/main"/>
           <a:p xmlns:a="http://schemas.openxmlformats.org/drawingml/2006/main">
             <a:pPr algn="r">
+              <a:buNone/>
               <a:defRPr sz="1200" b="0">
                 <a:solidFill>
                   <a:srgbClr val="56646B"/>
@@ -8440,6 +8356,7 @@
           <a:lstStyle xmlns:a="http://schemas.openxmlformats.org/drawingml/2006/main"/>
           <a:p xmlns:a="http://schemas.openxmlformats.org/drawingml/2006/main">
             <a:pPr algn="l">
+              <a:buNone/>
               <a:defRPr sz="1800" b="1">
                 <a:solidFill>
                   <a:srgbClr val="0F5B5A"/>
@@ -8490,6 +8407,7 @@
           <a:lstStyle xmlns:a="http://schemas.openxmlformats.org/drawingml/2006/main"/>
           <a:p xmlns:a="http://schemas.openxmlformats.org/drawingml/2006/main">
             <a:pPr algn="l">
+              <a:buNone/>
               <a:defRPr sz="1650" b="1">
                 <a:solidFill>
                   <a:srgbClr val="153F3E"/>
@@ -8540,6 +8458,7 @@
           <a:lstStyle xmlns:a="http://schemas.openxmlformats.org/drawingml/2006/main"/>
           <a:p xmlns:a="http://schemas.openxmlformats.org/drawingml/2006/main">
             <a:pPr algn="l">
+              <a:buNone/>
               <a:defRPr sz="1350" b="0">
                 <a:solidFill>
                   <a:srgbClr val="20262B"/>
@@ -8557,6 +8476,7 @@
           </a:p>
           <a:p xmlns:a="http://schemas.openxmlformats.org/drawingml/2006/main">
             <a:pPr algn="l">
+              <a:buNone/>
               <a:defRPr sz="1350" b="0">
                 <a:solidFill>
                   <a:srgbClr val="20262B"/>
@@ -8642,6 +8562,7 @@
           <a:lstStyle xmlns:a="http://schemas.openxmlformats.org/drawingml/2006/main"/>
           <a:p xmlns:a="http://schemas.openxmlformats.org/drawingml/2006/main">
             <a:pPr algn="l">
+              <a:buNone/>
               <a:defRPr sz="1800" b="1">
                 <a:solidFill>
                   <a:srgbClr val="0F5B5A"/>
@@ -8692,6 +8613,7 @@
           <a:lstStyle xmlns:a="http://schemas.openxmlformats.org/drawingml/2006/main"/>
           <a:p xmlns:a="http://schemas.openxmlformats.org/drawingml/2006/main">
             <a:pPr algn="l">
+              <a:buNone/>
               <a:defRPr sz="1650" b="1">
                 <a:solidFill>
                   <a:srgbClr val="153F3E"/>
@@ -8742,6 +8664,7 @@
           <a:lstStyle xmlns:a="http://schemas.openxmlformats.org/drawingml/2006/main"/>
           <a:p xmlns:a="http://schemas.openxmlformats.org/drawingml/2006/main">
             <a:pPr algn="l">
+              <a:buNone/>
               <a:defRPr sz="1350" b="0">
                 <a:solidFill>
                   <a:srgbClr val="20262B"/>
@@ -8759,6 +8682,7 @@
           </a:p>
           <a:p xmlns:a="http://schemas.openxmlformats.org/drawingml/2006/main">
             <a:pPr algn="l">
+              <a:buNone/>
               <a:defRPr sz="1350" b="0">
                 <a:solidFill>
                   <a:srgbClr val="20262B"/>
@@ -8844,6 +8768,7 @@
           <a:lstStyle xmlns:a="http://schemas.openxmlformats.org/drawingml/2006/main"/>
           <a:p xmlns:a="http://schemas.openxmlformats.org/drawingml/2006/main">
             <a:pPr algn="l">
+              <a:buNone/>
               <a:defRPr sz="1800" b="1">
                 <a:solidFill>
                   <a:srgbClr val="0F5B5A"/>
@@ -8894,6 +8819,7 @@
           <a:lstStyle xmlns:a="http://schemas.openxmlformats.org/drawingml/2006/main"/>
           <a:p xmlns:a="http://schemas.openxmlformats.org/drawingml/2006/main">
             <a:pPr algn="l">
+              <a:buNone/>
               <a:defRPr sz="1650" b="1">
                 <a:solidFill>
                   <a:srgbClr val="153F3E"/>
@@ -8944,6 +8870,7 @@
           <a:lstStyle xmlns:a="http://schemas.openxmlformats.org/drawingml/2006/main"/>
           <a:p xmlns:a="http://schemas.openxmlformats.org/drawingml/2006/main">
             <a:pPr algn="l">
+              <a:buNone/>
               <a:defRPr sz="1350" b="0">
                 <a:solidFill>
                   <a:srgbClr val="20262B"/>
@@ -8961,6 +8888,7 @@
           </a:p>
           <a:p xmlns:a="http://schemas.openxmlformats.org/drawingml/2006/main">
             <a:pPr algn="l">
+              <a:buNone/>
               <a:defRPr sz="1350" b="0">
                 <a:solidFill>
                   <a:srgbClr val="20262B"/>
@@ -9046,6 +8974,7 @@
           <a:lstStyle xmlns:a="http://schemas.openxmlformats.org/drawingml/2006/main"/>
           <a:p xmlns:a="http://schemas.openxmlformats.org/drawingml/2006/main">
             <a:pPr algn="l">
+              <a:buNone/>
               <a:defRPr sz="1800" b="1">
                 <a:solidFill>
                   <a:srgbClr val="0F5B5A"/>
@@ -9096,6 +9025,7 @@
           <a:lstStyle xmlns:a="http://schemas.openxmlformats.org/drawingml/2006/main"/>
           <a:p xmlns:a="http://schemas.openxmlformats.org/drawingml/2006/main">
             <a:pPr algn="l">
+              <a:buNone/>
               <a:defRPr sz="1650" b="1">
                 <a:solidFill>
                   <a:srgbClr val="153F3E"/>
@@ -9108,7 +9038,7 @@
                   <a:srgbClr val="153F3E"/>
                 </a:solidFill>
               </a:rPr>
-              <a:t>ML experiment</a:t>
+              <a:t>Frozen ML evaluation</a:t>
             </a:r>
           </a:p>
         </p:txBody>
@@ -9146,6 +9076,7 @@
           <a:lstStyle xmlns:a="http://schemas.openxmlformats.org/drawingml/2006/main"/>
           <a:p xmlns:a="http://schemas.openxmlformats.org/drawingml/2006/main">
             <a:pPr algn="l">
+              <a:buNone/>
               <a:defRPr sz="1350" b="0">
                 <a:solidFill>
                   <a:srgbClr val="20262B"/>
@@ -9158,11 +9089,12 @@
                   <a:srgbClr val="20262B"/>
                 </a:solidFill>
               </a:rPr>
-              <a:t>2015–19 train</a:t>
-            </a:r>
-          </a:p>
-          <a:p xmlns:a="http://schemas.openxmlformats.org/drawingml/2006/main">
-            <a:pPr algn="l">
+              <a:t>2010–19 fit</a:t>
+            </a:r>
+          </a:p>
+          <a:p xmlns:a="http://schemas.openxmlformats.org/drawingml/2006/main">
+            <a:pPr algn="l">
+              <a:buNone/>
               <a:defRPr sz="1350" b="0">
                 <a:solidFill>
                   <a:srgbClr val="20262B"/>
@@ -9176,6 +9108,24 @@
                 </a:solidFill>
               </a:rPr>
               <a:t>2020–21 validate</a:t>
+            </a:r>
+          </a:p>
+          <a:p xmlns:a="http://schemas.openxmlformats.org/drawingml/2006/main">
+            <a:pPr algn="l">
+              <a:buNone/>
+              <a:defRPr sz="1350" b="0">
+                <a:solidFill>
+                  <a:srgbClr val="20262B"/>
+                </a:solidFill>
+              </a:defRPr>
+            </a:pPr>
+            <a:r>
+              <a:rPr sz="1350" b="0">
+                <a:solidFill>
+                  <a:srgbClr val="20262B"/>
+                </a:solidFill>
+              </a:rPr>
+              <a:t>2022–24 test</a:t>
             </a:r>
           </a:p>
         </p:txBody>
@@ -9248,6 +9198,7 @@
           <a:lstStyle xmlns:a="http://schemas.openxmlformats.org/drawingml/2006/main"/>
           <a:p xmlns:a="http://schemas.openxmlformats.org/drawingml/2006/main">
             <a:pPr algn="l">
+              <a:buNone/>
               <a:defRPr sz="1800" b="1">
                 <a:solidFill>
                   <a:srgbClr val="0F5B5A"/>
@@ -9298,6 +9249,7 @@
           <a:lstStyle xmlns:a="http://schemas.openxmlformats.org/drawingml/2006/main"/>
           <a:p xmlns:a="http://schemas.openxmlformats.org/drawingml/2006/main">
             <a:pPr algn="l">
+              <a:buNone/>
               <a:defRPr sz="1650" b="1">
                 <a:solidFill>
                   <a:srgbClr val="153F3E"/>
@@ -9348,6 +9300,7 @@
           <a:lstStyle xmlns:a="http://schemas.openxmlformats.org/drawingml/2006/main"/>
           <a:p xmlns:a="http://schemas.openxmlformats.org/drawingml/2006/main">
             <a:pPr algn="l">
+              <a:buNone/>
               <a:defRPr sz="1350" b="0">
                 <a:solidFill>
                   <a:srgbClr val="20262B"/>
@@ -9365,6 +9318,7 @@
           </a:p>
           <a:p xmlns:a="http://schemas.openxmlformats.org/drawingml/2006/main">
             <a:pPr algn="l">
+              <a:buNone/>
               <a:defRPr sz="1350" b="0">
                 <a:solidFill>
                   <a:srgbClr val="20262B"/>
@@ -9450,6 +9404,7 @@
           <a:lstStyle xmlns:a="http://schemas.openxmlformats.org/drawingml/2006/main"/>
           <a:p xmlns:a="http://schemas.openxmlformats.org/drawingml/2006/main">
             <a:pPr algn="l">
+              <a:buNone/>
               <a:defRPr sz="1800" b="1">
                 <a:solidFill>
                   <a:srgbClr val="0F5B5A"/>
@@ -9500,6 +9455,7 @@
           <a:lstStyle xmlns:a="http://schemas.openxmlformats.org/drawingml/2006/main"/>
           <a:p xmlns:a="http://schemas.openxmlformats.org/drawingml/2006/main">
             <a:pPr algn="l">
+              <a:buNone/>
               <a:defRPr sz="1650" b="1">
                 <a:solidFill>
                   <a:srgbClr val="153F3E"/>
@@ -9550,6 +9506,7 @@
           <a:lstStyle xmlns:a="http://schemas.openxmlformats.org/drawingml/2006/main"/>
           <a:p xmlns:a="http://schemas.openxmlformats.org/drawingml/2006/main">
             <a:pPr algn="l">
+              <a:buNone/>
               <a:defRPr sz="1350" b="0">
                 <a:solidFill>
                   <a:srgbClr val="20262B"/>
@@ -9567,6 +9524,7 @@
           </a:p>
           <a:p xmlns:a="http://schemas.openxmlformats.org/drawingml/2006/main">
             <a:pPr algn="l">
+              <a:buNone/>
               <a:defRPr sz="1350" b="0">
                 <a:solidFill>
                   <a:srgbClr val="20262B"/>
@@ -9652,6 +9610,7 @@
           <a:lstStyle xmlns:a="http://schemas.openxmlformats.org/drawingml/2006/main"/>
           <a:p xmlns:a="http://schemas.openxmlformats.org/drawingml/2006/main">
             <a:pPr algn="l">
+              <a:buNone/>
               <a:defRPr sz="2025" b="1">
                 <a:solidFill>
                   <a:srgbClr val="153F3E"/>
@@ -9664,7 +9623,7 @@
                   <a:srgbClr val="153F3E"/>
                 </a:solidFill>
               </a:rPr>
-              <a:t>Attempted regression context</a:t>
+              <a:t>Nine-feature model context</a:t>
             </a:r>
           </a:p>
         </p:txBody>
@@ -9702,6 +9661,7 @@
           <a:lstStyle xmlns:a="http://schemas.openxmlformats.org/drawingml/2006/main"/>
           <a:p xmlns:a="http://schemas.openxmlformats.org/drawingml/2006/main">
             <a:pPr algn="l">
+              <a:buNone/>
               <a:defRPr sz="1650" b="0">
                 <a:solidFill>
                   <a:srgbClr val="20262B"/>
@@ -9752,6 +9712,7 @@
           <a:lstStyle xmlns:a="http://schemas.openxmlformats.org/drawingml/2006/main"/>
           <a:p xmlns:a="http://schemas.openxmlformats.org/drawingml/2006/main">
             <a:pPr algn="l">
+              <a:buNone/>
               <a:defRPr sz="1650" b="1">
                 <a:solidFill>
                   <a:srgbClr val="9B2226"/>
@@ -9831,6 +9792,7 @@
           <a:lstStyle xmlns:a="http://schemas.openxmlformats.org/drawingml/2006/main"/>
           <a:p xmlns:a="http://schemas.openxmlformats.org/drawingml/2006/main">
             <a:pPr algn="l">
+              <a:buNone/>
               <a:defRPr sz="3600" b="1">
                 <a:solidFill>
                   <a:srgbClr val="20262B"/>
@@ -9914,6 +9876,7 @@
           <a:lstStyle xmlns:a="http://schemas.openxmlformats.org/drawingml/2006/main"/>
           <a:p xmlns:a="http://schemas.openxmlformats.org/drawingml/2006/main">
             <a:pPr algn="r">
+              <a:buNone/>
               <a:defRPr sz="1200" b="0">
                 <a:solidFill>
                   <a:srgbClr val="56646B"/>
@@ -9964,6 +9927,7 @@
           <a:lstStyle xmlns:a="http://schemas.openxmlformats.org/drawingml/2006/main"/>
           <a:p xmlns:a="http://schemas.openxmlformats.org/drawingml/2006/main">
             <a:pPr algn="l">
+              <a:buNone/>
               <a:defRPr sz="2550" b="1">
                 <a:solidFill>
                   <a:srgbClr val="153F3E"/>
@@ -10014,6 +9978,7 @@
           <a:lstStyle xmlns:a="http://schemas.openxmlformats.org/drawingml/2006/main"/>
           <a:p xmlns:a="http://schemas.openxmlformats.org/drawingml/2006/main">
             <a:pPr algn="l">
+              <a:buNone/>
               <a:defRPr sz="1875" b="0">
                 <a:solidFill>
                   <a:srgbClr val="20262B"/>
@@ -10064,6 +10029,7 @@
           <a:lstStyle xmlns:a="http://schemas.openxmlformats.org/drawingml/2006/main"/>
           <a:p xmlns:a="http://schemas.openxmlformats.org/drawingml/2006/main">
             <a:pPr algn="l">
+              <a:buNone/>
               <a:defRPr sz="8100" b="1">
                 <a:solidFill>
                   <a:srgbClr val="C8D1D4"/>
@@ -10114,6 +10080,7 @@
           <a:lstStyle xmlns:a="http://schemas.openxmlformats.org/drawingml/2006/main"/>
           <a:p xmlns:a="http://schemas.openxmlformats.org/drawingml/2006/main">
             <a:pPr algn="l">
+              <a:buNone/>
               <a:defRPr sz="1800" b="1">
                 <a:solidFill>
                   <a:srgbClr val="56646B"/>
@@ -10197,6 +10164,7 @@
           <a:lstStyle xmlns:a="http://schemas.openxmlformats.org/drawingml/2006/main"/>
           <a:p xmlns:a="http://schemas.openxmlformats.org/drawingml/2006/main">
             <a:pPr algn="l">
+              <a:buNone/>
               <a:defRPr sz="2250" b="1">
                 <a:solidFill>
                   <a:srgbClr val="153F3E"/>
@@ -10247,6 +10215,7 @@
           <a:lstStyle xmlns:a="http://schemas.openxmlformats.org/drawingml/2006/main"/>
           <a:p xmlns:a="http://schemas.openxmlformats.org/drawingml/2006/main">
             <a:pPr algn="l">
+              <a:buNone/>
               <a:defRPr sz="2100" b="1">
                 <a:solidFill>
                   <a:srgbClr val="0F5B5A"/>
@@ -10297,6 +10266,7 @@
           <a:lstStyle xmlns:a="http://schemas.openxmlformats.org/drawingml/2006/main"/>
           <a:p xmlns:a="http://schemas.openxmlformats.org/drawingml/2006/main">
             <a:pPr algn="l">
+              <a:buNone/>
               <a:defRPr sz="1575" b="0">
                 <a:solidFill>
                   <a:srgbClr val="20262B"/>
@@ -10380,6 +10350,7 @@
           <a:lstStyle xmlns:a="http://schemas.openxmlformats.org/drawingml/2006/main"/>
           <a:p xmlns:a="http://schemas.openxmlformats.org/drawingml/2006/main">
             <a:pPr algn="l">
+              <a:buNone/>
               <a:defRPr sz="2100" b="1">
                 <a:solidFill>
                   <a:srgbClr val="0F5B5A"/>
@@ -10430,6 +10401,7 @@
           <a:lstStyle xmlns:a="http://schemas.openxmlformats.org/drawingml/2006/main"/>
           <a:p xmlns:a="http://schemas.openxmlformats.org/drawingml/2006/main">
             <a:pPr algn="l">
+              <a:buNone/>
               <a:defRPr sz="1575" b="0">
                 <a:solidFill>
                   <a:srgbClr val="20262B"/>
@@ -10513,6 +10485,7 @@
           <a:lstStyle xmlns:a="http://schemas.openxmlformats.org/drawingml/2006/main"/>
           <a:p xmlns:a="http://schemas.openxmlformats.org/drawingml/2006/main">
             <a:pPr algn="l">
+              <a:buNone/>
               <a:defRPr sz="2100" b="1">
                 <a:solidFill>
                   <a:srgbClr val="0F5B5A"/>
@@ -10563,6 +10536,7 @@
           <a:lstStyle xmlns:a="http://schemas.openxmlformats.org/drawingml/2006/main"/>
           <a:p xmlns:a="http://schemas.openxmlformats.org/drawingml/2006/main">
             <a:pPr algn="l">
+              <a:buNone/>
               <a:defRPr sz="1575" b="0">
                 <a:solidFill>
                   <a:srgbClr val="20262B"/>
@@ -10681,6 +10655,7 @@
           <a:lstStyle xmlns:a="http://schemas.openxmlformats.org/drawingml/2006/main"/>
           <a:p xmlns:a="http://schemas.openxmlformats.org/drawingml/2006/main">
             <a:pPr algn="l">
+              <a:buNone/>
               <a:defRPr sz="1650" b="1">
                 <a:solidFill>
                   <a:srgbClr val="153F3E"/>
@@ -10693,7 +10668,7 @@
                   <a:srgbClr val="153F3E"/>
                 </a:solidFill>
               </a:rPr>
-              <a:t>Useful comparative prioritisation needs error and ranking evidence.</a:t>
+              <a:t>Comparative estimates require error, calibration, and ranking evidence.</a:t>
             </a:r>
           </a:p>
         </p:txBody>
@@ -10760,6 +10735,7 @@
           <a:lstStyle xmlns:a="http://schemas.openxmlformats.org/drawingml/2006/main"/>
           <a:p xmlns:a="http://schemas.openxmlformats.org/drawingml/2006/main">
             <a:pPr algn="l">
+              <a:buNone/>
               <a:defRPr sz="3600" b="1">
                 <a:solidFill>
                   <a:srgbClr val="20262B"/>
@@ -10772,7 +10748,7 @@
                   <a:srgbClr val="20262B"/>
                 </a:solidFill>
               </a:rPr>
-              <a:t>Validation rejected both predictive candidates</a:t>
+              <a:t>Nine-feature hurdle: lower MAE, better ranking</a:t>
             </a:r>
           </a:p>
         </p:txBody>
@@ -10843,6 +10819,7 @@
           <a:lstStyle xmlns:a="http://schemas.openxmlformats.org/drawingml/2006/main"/>
           <a:p xmlns:a="http://schemas.openxmlformats.org/drawingml/2006/main">
             <a:pPr algn="r">
+              <a:buNone/>
               <a:defRPr sz="1200" b="0">
                 <a:solidFill>
                   <a:srgbClr val="56646B"/>
@@ -10862,18 +10839,18 @@
       </p:sp>
       <p:pic>
         <p:nvPicPr>
-          <p:cNvPr id="10" name=""/>
+          <p:cNvPr id="12" name=""/>
           <p:cNvPicPr>
             <a:picLocks xmlns:a="http://schemas.openxmlformats.org/drawingml/2006/main" noChangeAspect="1"/>
           </p:cNvPicPr>
           <p:nvPr/>
         </p:nvPicPr>
         <p:blipFill>
-          <a:blip xmlns:r="http://schemas.openxmlformats.org/officeDocument/2006/relationships" xmlns:a="http://schemas.openxmlformats.org/drawingml/2006/main" r:embed="Ra4310405ba5141fa"/>
+          <a:blip xmlns:r="http://schemas.openxmlformats.org/officeDocument/2006/relationships" xmlns:a="http://schemas.openxmlformats.org/drawingml/2006/main" r:embed="R9ec942eb107b4ffb"/>
           <a:stretch xmlns:a="http://schemas.openxmlformats.org/drawingml/2006/main"/>
         </p:blipFill>
         <p:spPr>
-          <a:xfrm xmlns:a="http://schemas.openxmlformats.org/drawingml/2006/main">
+          <a:xfrm xmlns:a="http://schemas.openxmlformats.org/drawingml/2006/main" flipH="0" flipV="0">
             <a:off x="571500" y="1088222"/>
             <a:ext cx="11049000" cy="4348181"/>
           </a:xfrm>
@@ -10950,6 +10927,7 @@
           <a:lstStyle xmlns:a="http://schemas.openxmlformats.org/drawingml/2006/main"/>
           <a:p xmlns:a="http://schemas.openxmlformats.org/drawingml/2006/main">
             <a:pPr algn="ctr">
+              <a:buNone/>
               <a:defRPr sz="1575" b="1">
                 <a:solidFill>
                   <a:srgbClr val="FFFFFF"/>
@@ -10962,7 +10940,7 @@
                   <a:srgbClr val="FFFFFF"/>
                 </a:solidFill>
               </a:rPr>
-              <a:t>The ML models were not selected for prediction; observed historical recurrence was retained as the final, directly interpretable screening classification.</a:t>
+              <a:t>On T=2022–2024, the hurdle reduced MAE and improved Capture@20% versus recurrence, while RMSE remained similar and the high-burn T=2024 outcome was underpredicted.</a:t>
             </a:r>
           </a:p>
         </p:txBody>
@@ -11029,6 +11007,7 @@
           <a:lstStyle xmlns:a="http://schemas.openxmlformats.org/drawingml/2006/main"/>
           <a:p xmlns:a="http://schemas.openxmlformats.org/drawingml/2006/main">
             <a:pPr algn="l">
+              <a:buNone/>
               <a:defRPr sz="3600" b="1">
                 <a:solidFill>
                   <a:srgbClr val="20262B"/>
@@ -11112,6 +11091,7 @@
           <a:lstStyle xmlns:a="http://schemas.openxmlformats.org/drawingml/2006/main"/>
           <a:p xmlns:a="http://schemas.openxmlformats.org/drawingml/2006/main">
             <a:pPr algn="r">
+              <a:buNone/>
               <a:defRPr sz="1200" b="0">
                 <a:solidFill>
                   <a:srgbClr val="56646B"/>
@@ -11263,6 +11243,7 @@
           <a:lstStyle xmlns:a="http://schemas.openxmlformats.org/drawingml/2006/main"/>
           <a:p xmlns:a="http://schemas.openxmlformats.org/drawingml/2006/main">
             <a:pPr algn="l">
+              <a:buNone/>
               <a:defRPr sz="2100" b="1">
                 <a:solidFill>
                   <a:srgbClr val="0F5B5A"/>
@@ -11313,6 +11294,7 @@
           <a:lstStyle xmlns:a="http://schemas.openxmlformats.org/drawingml/2006/main"/>
           <a:p xmlns:a="http://schemas.openxmlformats.org/drawingml/2006/main">
             <a:pPr algn="l">
+              <a:buNone/>
               <a:defRPr sz="1950" b="1">
                 <a:solidFill>
                   <a:srgbClr val="153F3E"/>
@@ -11363,6 +11345,7 @@
           <a:lstStyle xmlns:a="http://schemas.openxmlformats.org/drawingml/2006/main"/>
           <a:p xmlns:a="http://schemas.openxmlformats.org/drawingml/2006/main">
             <a:pPr algn="l">
+              <a:buNone/>
               <a:defRPr sz="1500" b="0">
                 <a:solidFill>
                   <a:srgbClr val="20262B"/>
@@ -11448,6 +11431,7 @@
           <a:lstStyle xmlns:a="http://schemas.openxmlformats.org/drawingml/2006/main"/>
           <a:p xmlns:a="http://schemas.openxmlformats.org/drawingml/2006/main">
             <a:pPr algn="l">
+              <a:buNone/>
               <a:defRPr sz="2100" b="1">
                 <a:solidFill>
                   <a:srgbClr val="0F5B5A"/>
@@ -11498,6 +11482,7 @@
           <a:lstStyle xmlns:a="http://schemas.openxmlformats.org/drawingml/2006/main"/>
           <a:p xmlns:a="http://schemas.openxmlformats.org/drawingml/2006/main">
             <a:pPr algn="l">
+              <a:buNone/>
               <a:defRPr sz="1950" b="1">
                 <a:solidFill>
                   <a:srgbClr val="153F3E"/>
@@ -11548,6 +11533,7 @@
           <a:lstStyle xmlns:a="http://schemas.openxmlformats.org/drawingml/2006/main"/>
           <a:p xmlns:a="http://schemas.openxmlformats.org/drawingml/2006/main">
             <a:pPr algn="l">
+              <a:buNone/>
               <a:defRPr sz="1500" b="0">
                 <a:solidFill>
                   <a:srgbClr val="20262B"/>
@@ -11633,6 +11619,7 @@
           <a:lstStyle xmlns:a="http://schemas.openxmlformats.org/drawingml/2006/main"/>
           <a:p xmlns:a="http://schemas.openxmlformats.org/drawingml/2006/main">
             <a:pPr algn="l">
+              <a:buNone/>
               <a:defRPr sz="2100" b="1">
                 <a:solidFill>
                   <a:srgbClr val="0F5B5A"/>
@@ -11683,6 +11670,7 @@
           <a:lstStyle xmlns:a="http://schemas.openxmlformats.org/drawingml/2006/main"/>
           <a:p xmlns:a="http://schemas.openxmlformats.org/drawingml/2006/main">
             <a:pPr algn="l">
+              <a:buNone/>
               <a:defRPr sz="1950" b="1">
                 <a:solidFill>
                   <a:srgbClr val="153F3E"/>
@@ -11733,6 +11721,7 @@
           <a:lstStyle xmlns:a="http://schemas.openxmlformats.org/drawingml/2006/main"/>
           <a:p xmlns:a="http://schemas.openxmlformats.org/drawingml/2006/main">
             <a:pPr algn="l">
+              <a:buNone/>
               <a:defRPr sz="1500" b="0">
                 <a:solidFill>
                   <a:srgbClr val="20262B"/>
@@ -11783,6 +11772,7 @@
           <a:lstStyle xmlns:a="http://schemas.openxmlformats.org/drawingml/2006/main"/>
           <a:p xmlns:a="http://schemas.openxmlformats.org/drawingml/2006/main">
             <a:pPr algn="l">
+              <a:buNone/>
               <a:defRPr sz="1650" b="1">
                 <a:solidFill>
                   <a:srgbClr val="9B2226"/>
@@ -11866,6 +11856,7 @@
           <a:lstStyle xmlns:a="http://schemas.openxmlformats.org/drawingml/2006/main"/>
           <a:p xmlns:a="http://schemas.openxmlformats.org/drawingml/2006/main">
             <a:pPr algn="l">
+              <a:buNone/>
               <a:defRPr sz="1425" b="1">
                 <a:solidFill>
                   <a:srgbClr val="FFFFFF"/>
@@ -11949,6 +11940,7 @@
           <a:lstStyle xmlns:a="http://schemas.openxmlformats.org/drawingml/2006/main"/>
           <a:p xmlns:a="http://schemas.openxmlformats.org/drawingml/2006/main">
             <a:pPr algn="l">
+              <a:buNone/>
               <a:defRPr sz="1425" b="1">
                 <a:solidFill>
                   <a:srgbClr val="FFFFFF"/>
@@ -12032,6 +12024,7 @@
           <a:lstStyle xmlns:a="http://schemas.openxmlformats.org/drawingml/2006/main"/>
           <a:p xmlns:a="http://schemas.openxmlformats.org/drawingml/2006/main">
             <a:pPr algn="l">
+              <a:buNone/>
               <a:defRPr sz="1425" b="1">
                 <a:solidFill>
                   <a:srgbClr val="FFFFFF"/>
@@ -12115,6 +12108,7 @@
           <a:lstStyle xmlns:a="http://schemas.openxmlformats.org/drawingml/2006/main"/>
           <a:p xmlns:a="http://schemas.openxmlformats.org/drawingml/2006/main">
             <a:pPr algn="l">
+              <a:buNone/>
               <a:defRPr sz="1425" b="1">
                 <a:solidFill>
                   <a:srgbClr val="FFFFFF"/>
@@ -12198,6 +12192,7 @@
           <a:lstStyle xmlns:a="http://schemas.openxmlformats.org/drawingml/2006/main"/>
           <a:p xmlns:a="http://schemas.openxmlformats.org/drawingml/2006/main">
             <a:pPr algn="l">
+              <a:buNone/>
               <a:defRPr sz="1500" b="0">
                 <a:solidFill>
                   <a:srgbClr val="20262B"/>
@@ -12281,6 +12276,7 @@
           <a:lstStyle xmlns:a="http://schemas.openxmlformats.org/drawingml/2006/main"/>
           <a:p xmlns:a="http://schemas.openxmlformats.org/drawingml/2006/main">
             <a:pPr algn="l">
+              <a:buNone/>
               <a:defRPr sz="1500" b="0">
                 <a:solidFill>
                   <a:srgbClr val="20262B"/>
@@ -12364,6 +12360,7 @@
           <a:lstStyle xmlns:a="http://schemas.openxmlformats.org/drawingml/2006/main"/>
           <a:p xmlns:a="http://schemas.openxmlformats.org/drawingml/2006/main">
             <a:pPr algn="l">
+              <a:buNone/>
               <a:defRPr sz="1500" b="0">
                 <a:solidFill>
                   <a:srgbClr val="20262B"/>
@@ -12447,6 +12444,7 @@
           <a:lstStyle xmlns:a="http://schemas.openxmlformats.org/drawingml/2006/main"/>
           <a:p xmlns:a="http://schemas.openxmlformats.org/drawingml/2006/main">
             <a:pPr algn="l">
+              <a:buNone/>
               <a:defRPr sz="1500" b="0">
                 <a:solidFill>
                   <a:srgbClr val="20262B"/>
@@ -12530,6 +12528,7 @@
           <a:lstStyle xmlns:a="http://schemas.openxmlformats.org/drawingml/2006/main"/>
           <a:p xmlns:a="http://schemas.openxmlformats.org/drawingml/2006/main">
             <a:pPr algn="l">
+              <a:buNone/>
               <a:defRPr sz="1500" b="0">
                 <a:solidFill>
                   <a:srgbClr val="20262B"/>
@@ -12613,6 +12612,7 @@
           <a:lstStyle xmlns:a="http://schemas.openxmlformats.org/drawingml/2006/main"/>
           <a:p xmlns:a="http://schemas.openxmlformats.org/drawingml/2006/main">
             <a:pPr algn="l">
+              <a:buNone/>
               <a:defRPr sz="1500" b="0">
                 <a:solidFill>
                   <a:srgbClr val="20262B"/>
@@ -12696,6 +12696,7 @@
           <a:lstStyle xmlns:a="http://schemas.openxmlformats.org/drawingml/2006/main"/>
           <a:p xmlns:a="http://schemas.openxmlformats.org/drawingml/2006/main">
             <a:pPr algn="l">
+              <a:buNone/>
               <a:defRPr sz="1500" b="0">
                 <a:solidFill>
                   <a:srgbClr val="20262B"/>
@@ -12779,6 +12780,7 @@
           <a:lstStyle xmlns:a="http://schemas.openxmlformats.org/drawingml/2006/main"/>
           <a:p xmlns:a="http://schemas.openxmlformats.org/drawingml/2006/main">
             <a:pPr algn="l">
+              <a:buNone/>
               <a:defRPr sz="1500" b="0">
                 <a:solidFill>
                   <a:srgbClr val="20262B"/>
@@ -12862,6 +12864,7 @@
           <a:lstStyle xmlns:a="http://schemas.openxmlformats.org/drawingml/2006/main"/>
           <a:p xmlns:a="http://schemas.openxmlformats.org/drawingml/2006/main">
             <a:pPr algn="l">
+              <a:buNone/>
               <a:defRPr sz="1500" b="0">
                 <a:solidFill>
                   <a:srgbClr val="20262B"/>
@@ -12945,6 +12948,7 @@
           <a:lstStyle xmlns:a="http://schemas.openxmlformats.org/drawingml/2006/main"/>
           <a:p xmlns:a="http://schemas.openxmlformats.org/drawingml/2006/main">
             <a:pPr algn="l">
+              <a:buNone/>
               <a:defRPr sz="1500" b="0">
                 <a:solidFill>
                   <a:srgbClr val="20262B"/>
@@ -13028,6 +13032,7 @@
           <a:lstStyle xmlns:a="http://schemas.openxmlformats.org/drawingml/2006/main"/>
           <a:p xmlns:a="http://schemas.openxmlformats.org/drawingml/2006/main">
             <a:pPr algn="l">
+              <a:buNone/>
               <a:defRPr sz="1500" b="0">
                 <a:solidFill>
                   <a:srgbClr val="20262B"/>
@@ -13111,6 +13116,7 @@
           <a:lstStyle xmlns:a="http://schemas.openxmlformats.org/drawingml/2006/main"/>
           <a:p xmlns:a="http://schemas.openxmlformats.org/drawingml/2006/main">
             <a:pPr algn="l">
+              <a:buNone/>
               <a:defRPr sz="1500" b="0">
                 <a:solidFill>
                   <a:srgbClr val="20262B"/>
@@ -13196,6 +13202,7 @@
           <a:lstStyle xmlns:a="http://schemas.openxmlformats.org/drawingml/2006/main"/>
           <a:p xmlns:a="http://schemas.openxmlformats.org/drawingml/2006/main">
             <a:pPr algn="ctr">
+              <a:buNone/>
               <a:defRPr sz="1650" b="1">
                 <a:solidFill>
                   <a:srgbClr val="153F3E"/>
@@ -13275,6 +13282,7 @@
           <a:lstStyle xmlns:a="http://schemas.openxmlformats.org/drawingml/2006/main"/>
           <a:p xmlns:a="http://schemas.openxmlformats.org/drawingml/2006/main">
             <a:pPr algn="l">
+              <a:buNone/>
               <a:defRPr sz="3600" b="1">
                 <a:solidFill>
                   <a:srgbClr val="20262B"/>
@@ -13358,6 +13366,7 @@
           <a:lstStyle xmlns:a="http://schemas.openxmlformats.org/drawingml/2006/main"/>
           <a:p xmlns:a="http://schemas.openxmlformats.org/drawingml/2006/main">
             <a:pPr algn="r">
+              <a:buNone/>
               <a:defRPr sz="1200" b="0">
                 <a:solidFill>
                   <a:srgbClr val="56646B"/>
@@ -13377,14 +13386,14 @@
       </p:sp>
       <p:pic>
         <p:nvPicPr>
-          <p:cNvPr id="21" name=""/>
+          <p:cNvPr id="23" name=""/>
           <p:cNvPicPr>
             <a:picLocks xmlns:a="http://schemas.openxmlformats.org/drawingml/2006/main" noChangeAspect="1"/>
           </p:cNvPicPr>
           <p:nvPr/>
         </p:nvPicPr>
         <p:blipFill>
-          <a:blip xmlns:r="http://schemas.openxmlformats.org/officeDocument/2006/relationships" xmlns:a="http://schemas.openxmlformats.org/drawingml/2006/main" r:embed="R86f8745700344d7d"/>
+          <a:blip xmlns:r="http://schemas.openxmlformats.org/officeDocument/2006/relationships" xmlns:a="http://schemas.openxmlformats.org/drawingml/2006/main" r:embed="R29f17b8c9d9e4047"/>
           <a:stretch xmlns:a="http://schemas.openxmlformats.org/drawingml/2006/main"/>
         </p:blipFill>
         <p:spPr>
@@ -13430,6 +13439,7 @@
           <a:lstStyle xmlns:a="http://schemas.openxmlformats.org/drawingml/2006/main"/>
           <a:p xmlns:a="http://schemas.openxmlformats.org/drawingml/2006/main">
             <a:pPr algn="l">
+              <a:buNone/>
               <a:defRPr sz="1500" b="1">
                 <a:solidFill>
                   <a:srgbClr val="0F5B5A"/>
@@ -13513,6 +13523,7 @@
           <a:lstStyle xmlns:a="http://schemas.openxmlformats.org/drawingml/2006/main"/>
           <a:p xmlns:a="http://schemas.openxmlformats.org/drawingml/2006/main">
             <a:pPr algn="l">
+              <a:buNone/>
               <a:defRPr sz="2025" b="1">
                 <a:solidFill>
                   <a:srgbClr val="20262B"/>
@@ -13563,6 +13574,7 @@
           <a:lstStyle xmlns:a="http://schemas.openxmlformats.org/drawingml/2006/main"/>
           <a:p xmlns:a="http://schemas.openxmlformats.org/drawingml/2006/main">
             <a:pPr algn="l">
+              <a:buNone/>
               <a:defRPr sz="1500" b="0">
                 <a:solidFill>
                   <a:srgbClr val="56646B"/>
@@ -13646,6 +13658,7 @@
           <a:lstStyle xmlns:a="http://schemas.openxmlformats.org/drawingml/2006/main"/>
           <a:p xmlns:a="http://schemas.openxmlformats.org/drawingml/2006/main">
             <a:pPr algn="l">
+              <a:buNone/>
               <a:defRPr sz="2025" b="1">
                 <a:solidFill>
                   <a:srgbClr val="20262B"/>
@@ -13696,6 +13709,7 @@
           <a:lstStyle xmlns:a="http://schemas.openxmlformats.org/drawingml/2006/main"/>
           <a:p xmlns:a="http://schemas.openxmlformats.org/drawingml/2006/main">
             <a:pPr algn="l">
+              <a:buNone/>
               <a:defRPr sz="1500" b="0">
                 <a:solidFill>
                   <a:srgbClr val="56646B"/>
@@ -13779,6 +13793,7 @@
           <a:lstStyle xmlns:a="http://schemas.openxmlformats.org/drawingml/2006/main"/>
           <a:p xmlns:a="http://schemas.openxmlformats.org/drawingml/2006/main">
             <a:pPr algn="l">
+              <a:buNone/>
               <a:defRPr sz="2025" b="1">
                 <a:solidFill>
                   <a:srgbClr val="20262B"/>
@@ -13829,6 +13844,7 @@
           <a:lstStyle xmlns:a="http://schemas.openxmlformats.org/drawingml/2006/main"/>
           <a:p xmlns:a="http://schemas.openxmlformats.org/drawingml/2006/main">
             <a:pPr algn="l">
+              <a:buNone/>
               <a:defRPr sz="1500" b="0">
                 <a:solidFill>
                   <a:srgbClr val="56646B"/>
@@ -13912,6 +13928,7 @@
           <a:lstStyle xmlns:a="http://schemas.openxmlformats.org/drawingml/2006/main"/>
           <a:p xmlns:a="http://schemas.openxmlformats.org/drawingml/2006/main">
             <a:pPr algn="l">
+              <a:buNone/>
               <a:defRPr sz="1725" b="1">
                 <a:solidFill>
                   <a:srgbClr val="153F3E"/>
@@ -13962,6 +13979,7 @@
           <a:lstStyle xmlns:a="http://schemas.openxmlformats.org/drawingml/2006/main"/>
           <a:p xmlns:a="http://schemas.openxmlformats.org/drawingml/2006/main">
             <a:pPr algn="l">
+              <a:buNone/>
               <a:defRPr sz="1500" b="1">
                 <a:solidFill>
                   <a:srgbClr val="9B2226"/>
@@ -14041,6 +14059,7 @@
           <a:lstStyle xmlns:a="http://schemas.openxmlformats.org/drawingml/2006/main"/>
           <a:p xmlns:a="http://schemas.openxmlformats.org/drawingml/2006/main">
             <a:pPr algn="l">
+              <a:buNone/>
               <a:defRPr sz="3600" b="1">
                 <a:solidFill>
                   <a:srgbClr val="20262B"/>
@@ -14124,6 +14143,7 @@
           <a:lstStyle xmlns:a="http://schemas.openxmlformats.org/drawingml/2006/main"/>
           <a:p xmlns:a="http://schemas.openxmlformats.org/drawingml/2006/main">
             <a:pPr algn="r">
+              <a:buNone/>
               <a:defRPr sz="1200" b="0">
                 <a:solidFill>
                   <a:srgbClr val="56646B"/>
@@ -14174,6 +14194,7 @@
           <a:lstStyle xmlns:a="http://schemas.openxmlformats.org/drawingml/2006/main"/>
           <a:p xmlns:a="http://schemas.openxmlformats.org/drawingml/2006/main">
             <a:pPr algn="l">
+              <a:buNone/>
               <a:defRPr sz="4575" b="1">
                 <a:solidFill>
                   <a:srgbClr val="153F3E"/>
@@ -14224,6 +14245,7 @@
           <a:lstStyle xmlns:a="http://schemas.openxmlformats.org/drawingml/2006/main"/>
           <a:p xmlns:a="http://schemas.openxmlformats.org/drawingml/2006/main">
             <a:pPr algn="l">
+              <a:buNone/>
               <a:defRPr sz="1875" b="1">
                 <a:solidFill>
                   <a:srgbClr val="20262B"/>
@@ -14307,6 +14329,7 @@
           <a:lstStyle xmlns:a="http://schemas.openxmlformats.org/drawingml/2006/main"/>
           <a:p xmlns:a="http://schemas.openxmlformats.org/drawingml/2006/main">
             <a:pPr algn="ctr">
+              <a:buNone/>
               <a:defRPr sz="1575" b="1">
                 <a:solidFill>
                   <a:srgbClr val="20262B"/>
@@ -14390,6 +14413,7 @@
           <a:lstStyle xmlns:a="http://schemas.openxmlformats.org/drawingml/2006/main"/>
           <a:p xmlns:a="http://schemas.openxmlformats.org/drawingml/2006/main">
             <a:pPr algn="ctr">
+              <a:buNone/>
               <a:defRPr sz="1575" b="1">
                 <a:solidFill>
                   <a:srgbClr val="20262B"/>
@@ -14473,6 +14497,7 @@
           <a:lstStyle xmlns:a="http://schemas.openxmlformats.org/drawingml/2006/main"/>
           <a:p xmlns:a="http://schemas.openxmlformats.org/drawingml/2006/main">
             <a:pPr algn="ctr">
+              <a:buNone/>
               <a:defRPr sz="1575" b="1">
                 <a:solidFill>
                   <a:srgbClr val="FFFFFF"/>
@@ -14556,6 +14581,7 @@
           <a:lstStyle xmlns:a="http://schemas.openxmlformats.org/drawingml/2006/main"/>
           <a:p xmlns:a="http://schemas.openxmlformats.org/drawingml/2006/main">
             <a:pPr algn="l">
+              <a:buNone/>
               <a:defRPr sz="2100" b="1">
                 <a:solidFill>
                   <a:srgbClr val="20262B"/>
@@ -14606,6 +14632,7 @@
           <a:lstStyle xmlns:a="http://schemas.openxmlformats.org/drawingml/2006/main"/>
           <a:p xmlns:a="http://schemas.openxmlformats.org/drawingml/2006/main">
             <a:pPr algn="l">
+              <a:buNone/>
               <a:defRPr sz="1725" b="0">
                 <a:solidFill>
                   <a:srgbClr val="153F3E"/>
@@ -14656,6 +14683,7 @@
           <a:lstStyle xmlns:a="http://schemas.openxmlformats.org/drawingml/2006/main"/>
           <a:p xmlns:a="http://schemas.openxmlformats.org/drawingml/2006/main">
             <a:pPr algn="l">
+              <a:buNone/>
               <a:defRPr sz="2325" b="1">
                 <a:solidFill>
                   <a:srgbClr val="0F5B5A"/>
@@ -14739,6 +14767,7 @@
           <a:lstStyle xmlns:a="http://schemas.openxmlformats.org/drawingml/2006/main"/>
           <a:p xmlns:a="http://schemas.openxmlformats.org/drawingml/2006/main">
             <a:pPr algn="l">
+              <a:buNone/>
               <a:defRPr sz="2100" b="1">
                 <a:solidFill>
                   <a:srgbClr val="20262B"/>
@@ -14789,6 +14818,7 @@
           <a:lstStyle xmlns:a="http://schemas.openxmlformats.org/drawingml/2006/main"/>
           <a:p xmlns:a="http://schemas.openxmlformats.org/drawingml/2006/main">
             <a:pPr algn="l">
+              <a:buNone/>
               <a:defRPr sz="1725" b="0">
                 <a:solidFill>
                   <a:srgbClr val="153F3E"/>
@@ -14839,6 +14869,7 @@
           <a:lstStyle xmlns:a="http://schemas.openxmlformats.org/drawingml/2006/main"/>
           <a:p xmlns:a="http://schemas.openxmlformats.org/drawingml/2006/main">
             <a:pPr algn="l">
+              <a:buNone/>
               <a:defRPr sz="2325" b="1">
                 <a:solidFill>
                   <a:srgbClr val="0F5B5A"/>
@@ -14922,6 +14953,7 @@
           <a:lstStyle xmlns:a="http://schemas.openxmlformats.org/drawingml/2006/main"/>
           <a:p xmlns:a="http://schemas.openxmlformats.org/drawingml/2006/main">
             <a:pPr algn="l">
+              <a:buNone/>
               <a:defRPr sz="2100" b="1">
                 <a:solidFill>
                   <a:srgbClr val="20262B"/>
@@ -14972,6 +15004,7 @@
           <a:lstStyle xmlns:a="http://schemas.openxmlformats.org/drawingml/2006/main"/>
           <a:p xmlns:a="http://schemas.openxmlformats.org/drawingml/2006/main">
             <a:pPr algn="l">
+              <a:buNone/>
               <a:defRPr sz="1725" b="0">
                 <a:solidFill>
                   <a:srgbClr val="153F3E"/>
@@ -15022,6 +15055,7 @@
           <a:lstStyle xmlns:a="http://schemas.openxmlformats.org/drawingml/2006/main"/>
           <a:p xmlns:a="http://schemas.openxmlformats.org/drawingml/2006/main">
             <a:pPr algn="l">
+              <a:buNone/>
               <a:defRPr sz="2325" b="1">
                 <a:solidFill>
                   <a:srgbClr val="0F5B5A"/>
@@ -15072,6 +15106,7 @@
           <a:lstStyle xmlns:a="http://schemas.openxmlformats.org/drawingml/2006/main"/>
           <a:p xmlns:a="http://schemas.openxmlformats.org/drawingml/2006/main">
             <a:pPr algn="ctr">
+              <a:buNone/>
               <a:defRPr sz="1575" b="1">
                 <a:solidFill>
                   <a:srgbClr val="153F3E"/>

</xml_diff>

<commit_message>
Finalize project documentation, notebooks, presentation, and repository cleanup.
</commit_message>
<xml_diff>
--- a/reports/presentation/v2_wildfire_exposure_screening_capstone_presentation.pptx
+++ b/reports/presentation/v2_wildfire_exposure_screening_capstone_presentation.pptx
@@ -2,25 +2,25 @@
 <file path=ppt/presentation.xml><?xml version="1.0" encoding="utf-8"?>
 <p:presentation xmlns:p="http://schemas.openxmlformats.org/presentationml/2006/main">
   <p:sldMasterIdLst>
-    <p:sldMasterId xmlns:r="http://schemas.openxmlformats.org/officeDocument/2006/relationships" id="2147483648" r:id="Rf447278a742a46ab"/>
+    <p:sldMasterId xmlns:r="http://schemas.openxmlformats.org/officeDocument/2006/relationships" id="2147483648" r:id="R36bc4d06ab0c47e2"/>
   </p:sldMasterIdLst>
   <p:notesMasterIdLst>
-    <p:notesMasterId xmlns:r="http://schemas.openxmlformats.org/officeDocument/2006/relationships" r:id="R65fc1dd77bca4a4a"/>
+    <p:notesMasterId xmlns:r="http://schemas.openxmlformats.org/officeDocument/2006/relationships" r:id="R4d3003866a9b470d"/>
   </p:notesMasterIdLst>
   <p:sldIdLst>
-    <p:sldId xmlns:r="http://schemas.openxmlformats.org/officeDocument/2006/relationships" id="256" r:id="Rc30e905a36f84a1a"/>
-    <p:sldId xmlns:r="http://schemas.openxmlformats.org/officeDocument/2006/relationships" id="257" r:id="Ref8b0f06bc9f48c0"/>
-    <p:sldId xmlns:r="http://schemas.openxmlformats.org/officeDocument/2006/relationships" id="258" r:id="Rb87d82ec033642be"/>
-    <p:sldId xmlns:r="http://schemas.openxmlformats.org/officeDocument/2006/relationships" id="259" r:id="Re3ba5cf09937400f"/>
-    <p:sldId xmlns:r="http://schemas.openxmlformats.org/officeDocument/2006/relationships" id="260" r:id="Ra56c93880690415b"/>
-    <p:sldId xmlns:r="http://schemas.openxmlformats.org/officeDocument/2006/relationships" id="261" r:id="Rf22deaba3cf24876"/>
-    <p:sldId xmlns:r="http://schemas.openxmlformats.org/officeDocument/2006/relationships" id="262" r:id="R26cae7a254314236"/>
-    <p:sldId xmlns:r="http://schemas.openxmlformats.org/officeDocument/2006/relationships" id="263" r:id="R00b26111c6fd4be2"/>
-    <p:sldId xmlns:r="http://schemas.openxmlformats.org/officeDocument/2006/relationships" id="264" r:id="Rb201b8953be14249"/>
-    <p:sldId xmlns:r="http://schemas.openxmlformats.org/officeDocument/2006/relationships" id="265" r:id="R02b486785d5d4eae"/>
-    <p:sldId xmlns:r="http://schemas.openxmlformats.org/officeDocument/2006/relationships" id="266" r:id="R83a1fa21b8914c29"/>
-    <p:sldId xmlns:r="http://schemas.openxmlformats.org/officeDocument/2006/relationships" id="267" r:id="Rd7d61544ab984904"/>
-    <p:sldId xmlns:r="http://schemas.openxmlformats.org/officeDocument/2006/relationships" id="268" r:id="R2625fe937ad84dd5"/>
+    <p:sldId xmlns:r="http://schemas.openxmlformats.org/officeDocument/2006/relationships" id="256" r:id="R052c1aaea9d244f4"/>
+    <p:sldId xmlns:r="http://schemas.openxmlformats.org/officeDocument/2006/relationships" id="257" r:id="R66ed581376e4402d"/>
+    <p:sldId xmlns:r="http://schemas.openxmlformats.org/officeDocument/2006/relationships" id="258" r:id="R4e27c8b07fca4eae"/>
+    <p:sldId xmlns:r="http://schemas.openxmlformats.org/officeDocument/2006/relationships" id="259" r:id="R1201e38b87044dfc"/>
+    <p:sldId xmlns:r="http://schemas.openxmlformats.org/officeDocument/2006/relationships" id="260" r:id="Rf84c22ac50e0439c"/>
+    <p:sldId xmlns:r="http://schemas.openxmlformats.org/officeDocument/2006/relationships" id="261" r:id="Rb8c0af4df18c4ed1"/>
+    <p:sldId xmlns:r="http://schemas.openxmlformats.org/officeDocument/2006/relationships" id="262" r:id="Rb0f59edef603488d"/>
+    <p:sldId xmlns:r="http://schemas.openxmlformats.org/officeDocument/2006/relationships" id="263" r:id="R20e8d85027d64584"/>
+    <p:sldId xmlns:r="http://schemas.openxmlformats.org/officeDocument/2006/relationships" id="264" r:id="R3fd5214e62b24337"/>
+    <p:sldId xmlns:r="http://schemas.openxmlformats.org/officeDocument/2006/relationships" id="265" r:id="Rec78b8a811b444dd"/>
+    <p:sldId xmlns:r="http://schemas.openxmlformats.org/officeDocument/2006/relationships" id="266" r:id="R595fdad1c6c14cf4"/>
+    <p:sldId xmlns:r="http://schemas.openxmlformats.org/officeDocument/2006/relationships" id="267" r:id="R1b8ac70c78e44d02"/>
+    <p:sldId xmlns:r="http://schemas.openxmlformats.org/officeDocument/2006/relationships" id="268" r:id="R1f09f0cbf94c4fea"/>
   </p:sldIdLst>
   <p:sldSz cx="12192000" cy="6858000"/>
   <p:notesSz cx="6858000" cy="9144000"/>
@@ -569,7 +569,7 @@
           <a:lstStyle xmlns:a="http://schemas.openxmlformats.org/drawingml/2006/main"/>
           <a:p xmlns:a="http://schemas.openxmlformats.org/drawingml/2006/main">
             <a:r>
-              <a:t>The left map asks how frequently each cell's context was affected in the observed 2016–2025 burned-area record. The right map shows the official ICNF structural wildfire-hazard classification for 2020–2030. The official source begins as a 25 m raster and is summarized to each 1 km cell using the predominant valid class. These layers measure related but different concepts: recent observed recurrence versus structural propensity under the official methodology.</a:t>
+              <a:t>The three maps use the same 89,112 mainland 1 km grid cells but answer different questions.</a:t>
             </a:r>
           </a:p>
           <a:p xmlns:a="http://schemas.openxmlformats.org/drawingml/2006/main">
@@ -579,7 +579,7 @@
           </a:p>
           <a:p xmlns:a="http://schemas.openxmlformats.org/drawingml/2006/main">
             <a:r>
-              <a:t>Key takeaway for the assessor: this is not prediction versus real fire data, and neither layer is used as an accuracy benchmark for the other.</a:t>
+              <a:t>The left map summarizes observed ICNF fire recurrence during 2016-2025, measured in a 2 km outward context around each 1 km cell. The centre map shows the official ICNF structural wildfire-hazard classification for 2020-2030, summarized from the 25 m raster to each 1 km cell by predominant valid class. The right map is separate: it applies the fixed nine-feature hurdle model to validated 2025 predictor inputs and groups the stored continuous 2026 comparative estimate into presentation percentiles.</a:t>
             </a:r>
           </a:p>
           <a:p xmlns:a="http://schemas.openxmlformats.org/drawingml/2006/main">
@@ -589,7 +589,7 @@
           </a:p>
           <a:p xmlns:a="http://schemas.openxmlformats.org/drawingml/2006/main">
             <a:r>
-              <a:t>Methodological nuance: exact modal ties in the official raster select the higher class; cells without valid official pixels remain unmatched rather than being assigned a low class.</a:t>
+              <a:t>These views are complementary, not interchangeable. The historical and official maps are descriptive evidence under different methods. The 2026 layer is a target-free model estimate; there is no observed 2026 outcome yet, so it has no 2026 error score. None is a property-level safety guarantee or purchase recommendation.</a:t>
             </a:r>
           </a:p>
           <a:p xmlns:a="http://schemas.openxmlformats.org/drawingml/2006/main">
@@ -599,27 +599,17 @@
           </a:p>
           <a:p xmlns:a="http://schemas.openxmlformats.org/drawingml/2006/main">
             <a:r>
-              <a:t>Likely assessor question and answer</a:t>
-            </a:r>
-          </a:p>
-          <a:p xmlns:a="http://schemas.openxmlformats.org/drawingml/2006/main">
-            <a:r>
-              <a:t>Why compare them? Agreement and disagreement reveal where recent observed recurrence aligns—or does not align—with the independent structural assessment, guiding further investigation.</a:t>
-            </a:r>
-          </a:p>
-          <a:p xmlns:a="http://schemas.openxmlformats.org/drawingml/2006/main">
-            <a:r>
-              <a:t/>
-            </a:r>
-          </a:p>
-          <a:p xmlns:a="http://schemas.openxmlformats.org/drawingml/2006/main">
-            <a:r>
               <a:t>[Sources]</a:t>
             </a:r>
           </a:p>
           <a:p xmlns:a="http://schemas.openxmlformats.org/drawingml/2006/main">
             <a:r>
-              <a:t>- reports/figures/historical_exposure_and_official_icnf_structural_hazard_comparison.png</a:t>
+              <a:t>- data/processed/spatial_outputs/historical_residential_wildfire_exposure_screening.gpkg</a:t>
+            </a:r>
+          </a:p>
+          <a:p xmlns:a="http://schemas.openxmlformats.org/drawingml/2006/main">
+            <a:r>
+              <a:t>- data/processed/spatial_outputs/estimated_comparative_wildfire_exposure_2026.gpkg</a:t>
             </a:r>
           </a:p>
           <a:p xmlns:a="http://schemas.openxmlformats.org/drawingml/2006/main">
@@ -629,7 +619,12 @@
           </a:p>
           <a:p xmlns:a="http://schemas.openxmlformats.org/drawingml/2006/main">
             <a:r>
-              <a:t>- ICNF SRUP structural wildfire hazard map 2020–2030</a:t>
+              <a:t>- reports/validation/operational_forecast_2026_validation.md</a:t>
+            </a:r>
+          </a:p>
+          <a:p xmlns:a="http://schemas.openxmlformats.org/drawingml/2006/main">
+            <a:r>
+              <a:t>- src/historical_screening_reporting.py</a:t>
             </a:r>
           </a:p>
         </p:txBody>
@@ -2037,7 +2032,7 @@
   </p:cSld>
   <p:clrMap bg1="lt1" tx1="dk1" bg2="lt2" tx2="dk2" accent1="accent1" accent2="accent2" accent3="accent3" accent4="accent4" accent5="accent5" accent6="accent6" hlink="hlink" folHlink="folHlink"/>
   <p:sldLayoutIdLst>
-    <p:sldLayoutId xmlns:r="http://schemas.openxmlformats.org/officeDocument/2006/relationships" id="2147483649" r:id="Rd58772ef7a0140cf"/>
+    <p:sldLayoutId xmlns:r="http://schemas.openxmlformats.org/officeDocument/2006/relationships" id="2147483649" r:id="R4aecbd17fe604cb0"/>
   </p:sldLayoutIdLst>
   <p:txStyles>
     <p:titleStyle>
@@ -2979,7 +2974,7 @@
                   <a:srgbClr val="20262B"/>
                 </a:solidFill>
               </a:rPr>
-              <a:t>The two maps answer different questions</a:t>
+              <a:t>Three maps answer different questions</a:t>
             </a:r>
           </a:p>
         </p:txBody>
@@ -3063,7 +3058,7 @@
                   <a:srgbClr val="56646B"/>
                 </a:solidFill>
               </a:rPr>
-              <a:t>Observed recurrence and official structural propensity are complementary</a:t>
+              <a:t>Observed history, official structure and the 2026 estimate are complementary</a:t>
             </a:r>
           </a:p>
         </p:txBody>
@@ -3128,13 +3123,13 @@
           <p:nvPr/>
         </p:nvPicPr>
         <p:blipFill>
-          <a:blip xmlns:r="http://schemas.openxmlformats.org/officeDocument/2006/relationships" xmlns:a="http://schemas.openxmlformats.org/drawingml/2006/main" r:embed="R1edb9f408cb64e36"/>
+          <a:blip xmlns:r="http://schemas.openxmlformats.org/officeDocument/2006/relationships" xmlns:a="http://schemas.openxmlformats.org/drawingml/2006/main" r:embed="R6f44ea23e55b4464"/>
           <a:stretch xmlns:a="http://schemas.openxmlformats.org/drawingml/2006/main"/>
         </p:blipFill>
         <p:spPr>
           <a:xfrm xmlns:a="http://schemas.openxmlformats.org/drawingml/2006/main">
-            <a:off x="2358590" y="1095375"/>
-            <a:ext cx="7474821" cy="5286375"/>
+            <a:off x="1241773" y="1190625"/>
+            <a:ext cx="9708455" cy="4953000"/>
           </a:xfrm>
           <a:prstGeom xmlns:a="http://schemas.openxmlformats.org/drawingml/2006/main" prst="rect">
             <a:avLst/>
@@ -3314,7 +3309,7 @@
           <p:nvPr/>
         </p:nvPicPr>
         <p:blipFill>
-          <a:blip xmlns:r="http://schemas.openxmlformats.org/officeDocument/2006/relationships" xmlns:a="http://schemas.openxmlformats.org/drawingml/2006/main" r:embed="R0f1c8c8d332c4a16"/>
+          <a:blip xmlns:r="http://schemas.openxmlformats.org/officeDocument/2006/relationships" xmlns:a="http://schemas.openxmlformats.org/drawingml/2006/main" r:embed="R0f6b10053cef4097"/>
           <a:stretch xmlns:a="http://schemas.openxmlformats.org/drawingml/2006/main"/>
         </p:blipFill>
         <p:spPr>
@@ -10846,7 +10841,7 @@
           <p:nvPr/>
         </p:nvPicPr>
         <p:blipFill>
-          <a:blip xmlns:r="http://schemas.openxmlformats.org/officeDocument/2006/relationships" xmlns:a="http://schemas.openxmlformats.org/drawingml/2006/main" r:embed="R9ec942eb107b4ffb"/>
+          <a:blip xmlns:r="http://schemas.openxmlformats.org/officeDocument/2006/relationships" xmlns:a="http://schemas.openxmlformats.org/drawingml/2006/main" r:embed="Rffb5aede18e94eb2"/>
           <a:stretch xmlns:a="http://schemas.openxmlformats.org/drawingml/2006/main"/>
         </p:blipFill>
         <p:spPr>
@@ -13393,7 +13388,7 @@
           <p:nvPr/>
         </p:nvPicPr>
         <p:blipFill>
-          <a:blip xmlns:r="http://schemas.openxmlformats.org/officeDocument/2006/relationships" xmlns:a="http://schemas.openxmlformats.org/drawingml/2006/main" r:embed="R29f17b8c9d9e4047"/>
+          <a:blip xmlns:r="http://schemas.openxmlformats.org/officeDocument/2006/relationships" xmlns:a="http://schemas.openxmlformats.org/drawingml/2006/main" r:embed="R8aa02e26a77b47f7"/>
           <a:stretch xmlns:a="http://schemas.openxmlformats.org/drawingml/2006/main"/>
         </p:blipFill>
         <p:spPr>

</xml_diff>